<commit_message>
docs: remove round label from Corvus pitch
</commit_message>
<xml_diff>
--- a/docs/pitch/round-2/corvus-round-2-therapy-pitch.pptx
+++ b/docs/pitch/round-2/corvus-round-2-therapy-pitch.pptx
@@ -2,16 +2,16 @@
 <file path=ppt/presentation.xml><?xml version="1.0" encoding="utf-8"?>
 <p:presentation xmlns:p="http://schemas.openxmlformats.org/presentationml/2006/main">
   <p:sldMasterIdLst>
-    <p:sldMasterId xmlns:r="http://schemas.openxmlformats.org/officeDocument/2006/relationships" id="2147483648" r:id="Rb55946b999764746"/>
+    <p:sldMasterId xmlns:r="http://schemas.openxmlformats.org/officeDocument/2006/relationships" id="2147483648" r:id="Rbe711ad7c3e44d03"/>
   </p:sldMasterIdLst>
   <p:notesMasterIdLst>
-    <p:notesMasterId xmlns:r="http://schemas.openxmlformats.org/officeDocument/2006/relationships" r:id="Ra83bbb1ffa8449ea"/>
+    <p:notesMasterId xmlns:r="http://schemas.openxmlformats.org/officeDocument/2006/relationships" r:id="R78b0746e36df4974"/>
   </p:notesMasterIdLst>
   <p:sldIdLst>
-    <p:sldId xmlns:r="http://schemas.openxmlformats.org/officeDocument/2006/relationships" id="256" r:id="R568a266ac03147ac"/>
-    <p:sldId xmlns:r="http://schemas.openxmlformats.org/officeDocument/2006/relationships" id="257" r:id="Rc54ad7774cf84b70"/>
-    <p:sldId xmlns:r="http://schemas.openxmlformats.org/officeDocument/2006/relationships" id="258" r:id="R67398b90e5ae48b3"/>
-    <p:sldId xmlns:r="http://schemas.openxmlformats.org/officeDocument/2006/relationships" id="259" r:id="R30691a98ae5d4ff9"/>
+    <p:sldId xmlns:r="http://schemas.openxmlformats.org/officeDocument/2006/relationships" id="256" r:id="Ra0f95b9e7cf74a34"/>
+    <p:sldId xmlns:r="http://schemas.openxmlformats.org/officeDocument/2006/relationships" id="257" r:id="R109e6990389f4a8a"/>
+    <p:sldId xmlns:r="http://schemas.openxmlformats.org/officeDocument/2006/relationships" id="258" r:id="R5c3f8b8ba9c64ae9"/>
+    <p:sldId xmlns:r="http://schemas.openxmlformats.org/officeDocument/2006/relationships" id="259" r:id="R912603da6b5f414c"/>
   </p:sldIdLst>
   <p:sldSz cx="12192000" cy="6858000"/>
   <p:notesSz cx="6858000" cy="9144000"/>
@@ -978,7 +978,7 @@
   </p:cSld>
   <p:clrMap bg1="lt1" tx1="dk1" bg2="lt2" tx2="dk2" accent1="accent1" accent2="accent2" accent3="accent3" accent4="accent4" accent5="accent5" accent6="accent6" hlink="hlink" folHlink="folHlink"/>
   <p:sldLayoutIdLst>
-    <p:sldLayoutId xmlns:r="http://schemas.openxmlformats.org/officeDocument/2006/relationships" id="2147483649" r:id="R90397d0076a24b8a"/>
+    <p:sldLayoutId xmlns:r="http://schemas.openxmlformats.org/officeDocument/2006/relationships" id="2147483649" r:id="Rfe0ee6e32cf34ebe"/>
   </p:sldLayoutIdLst>
   <p:txStyles>
     <p:titleStyle>
@@ -1574,22 +1574,187 @@
       </p:sp>
       <p:sp>
         <p:nvSpPr>
-          <p:cNvPr id="2" name="round-2">
-            <a:extLst xmlns:a="http://schemas.openxmlformats.org/drawingml/2006/main">
-              <a:ext uri="{FF2B5EF4-FFF2-40B4-BE49-F238E27FC236}">
-                <a16:creationId xmlns:a16="http://schemas.microsoft.com/office/drawing/2014/main" id="{BE011543-B5AB-45AA-B844-F875940BF3A5}"/>
-              </a:ext>
-            </a:extLst>
-          </p:cNvPr>
-          <p:cNvSpPr>
-            <a:spLocks xmlns:a="http://schemas.openxmlformats.org/drawingml/2006/main" noGrp="1"/>
-          </p:cNvSpPr>
-          <p:nvPr/>
-        </p:nvSpPr>
-        <p:spPr>
-          <a:xfrm xmlns:a="http://schemas.openxmlformats.org/drawingml/2006/main">
-            <a:off x="9334500" y="247650"/>
-            <a:ext cx="2400300" cy="247650"/>
+          <p:cNvPr id="3" name="top-rule-2">
+            <a:extLst xmlns:a="http://schemas.openxmlformats.org/drawingml/2006/main">
+              <a:ext uri="{FF2B5EF4-FFF2-40B4-BE49-F238E27FC236}">
+                <a16:creationId xmlns:a16="http://schemas.microsoft.com/office/drawing/2014/main" id="{396DF957-A8C7-49AC-BAE3-958FDBC5C4E6}"/>
+              </a:ext>
+            </a:extLst>
+          </p:cNvPr>
+          <p:cNvSpPr>
+            <a:spLocks xmlns:a="http://schemas.openxmlformats.org/drawingml/2006/main" noGrp="1"/>
+          </p:cNvSpPr>
+          <p:nvPr/>
+        </p:nvSpPr>
+        <p:spPr>
+          <a:xfrm xmlns:a="http://schemas.openxmlformats.org/drawingml/2006/main">
+            <a:off x="457200" y="609600"/>
+            <a:ext cx="11277600" cy="9525"/>
+          </a:xfrm>
+          <a:prstGeom xmlns:a="http://schemas.openxmlformats.org/drawingml/2006/main" prst="rect">
+            <a:avLst/>
+          </a:prstGeom>
+          <a:solidFill xmlns:a="http://schemas.openxmlformats.org/drawingml/2006/main">
+            <a:srgbClr val="262626"/>
+          </a:solidFill>
+          <a:ln xmlns:a="http://schemas.openxmlformats.org/drawingml/2006/main" w="0">
+            <a:solidFill>
+              <a:srgbClr val="262626"/>
+            </a:solidFill>
+            <a:prstDash val="solid"/>
+          </a:ln>
+        </p:spPr>
+      </p:sp>
+      <p:sp>
+        <p:nvSpPr>
+          <p:cNvPr id="4" name="left-grid-2">
+            <a:extLst xmlns:a="http://schemas.openxmlformats.org/drawingml/2006/main">
+              <a:ext uri="{FF2B5EF4-FFF2-40B4-BE49-F238E27FC236}">
+                <a16:creationId xmlns:a16="http://schemas.microsoft.com/office/drawing/2014/main" id="{8D51CE1C-3BF4-46F9-A35E-65FE60844823}"/>
+              </a:ext>
+            </a:extLst>
+          </p:cNvPr>
+          <p:cNvSpPr>
+            <a:spLocks xmlns:a="http://schemas.openxmlformats.org/drawingml/2006/main" noGrp="1"/>
+          </p:cNvSpPr>
+          <p:nvPr/>
+        </p:nvSpPr>
+        <p:spPr>
+          <a:xfrm xmlns:a="http://schemas.openxmlformats.org/drawingml/2006/main">
+            <a:off x="457200" y="609600"/>
+            <a:ext cx="9525" cy="5753100"/>
+          </a:xfrm>
+          <a:prstGeom xmlns:a="http://schemas.openxmlformats.org/drawingml/2006/main" prst="rect">
+            <a:avLst/>
+          </a:prstGeom>
+          <a:solidFill xmlns:a="http://schemas.openxmlformats.org/drawingml/2006/main">
+            <a:srgbClr val="262626"/>
+          </a:solidFill>
+          <a:ln xmlns:a="http://schemas.openxmlformats.org/drawingml/2006/main" w="0">
+            <a:solidFill>
+              <a:srgbClr val="262626"/>
+            </a:solidFill>
+            <a:prstDash val="solid"/>
+          </a:ln>
+        </p:spPr>
+      </p:sp>
+      <p:sp>
+        <p:nvSpPr>
+          <p:cNvPr id="5" name="center-grid-2">
+            <a:extLst xmlns:a="http://schemas.openxmlformats.org/drawingml/2006/main">
+              <a:ext uri="{FF2B5EF4-FFF2-40B4-BE49-F238E27FC236}">
+                <a16:creationId xmlns:a16="http://schemas.microsoft.com/office/drawing/2014/main" id="{F3A88BBC-ECA8-430A-AAC3-873FA03A4391}"/>
+              </a:ext>
+            </a:extLst>
+          </p:cNvPr>
+          <p:cNvSpPr>
+            <a:spLocks xmlns:a="http://schemas.openxmlformats.org/drawingml/2006/main" noGrp="1"/>
+          </p:cNvSpPr>
+          <p:nvPr/>
+        </p:nvSpPr>
+        <p:spPr>
+          <a:xfrm xmlns:a="http://schemas.openxmlformats.org/drawingml/2006/main">
+            <a:off x="6096000" y="609600"/>
+            <a:ext cx="9525" cy="5753100"/>
+          </a:xfrm>
+          <a:prstGeom xmlns:a="http://schemas.openxmlformats.org/drawingml/2006/main" prst="rect">
+            <a:avLst/>
+          </a:prstGeom>
+          <a:solidFill xmlns:a="http://schemas.openxmlformats.org/drawingml/2006/main">
+            <a:srgbClr val="262626"/>
+          </a:solidFill>
+          <a:ln xmlns:a="http://schemas.openxmlformats.org/drawingml/2006/main" w="0">
+            <a:solidFill>
+              <a:srgbClr val="262626"/>
+            </a:solidFill>
+            <a:prstDash val="solid"/>
+          </a:ln>
+        </p:spPr>
+      </p:sp>
+      <p:sp>
+        <p:nvSpPr>
+          <p:cNvPr id="6" name="right-grid-2">
+            <a:extLst xmlns:a="http://schemas.openxmlformats.org/drawingml/2006/main">
+              <a:ext uri="{FF2B5EF4-FFF2-40B4-BE49-F238E27FC236}">
+                <a16:creationId xmlns:a16="http://schemas.microsoft.com/office/drawing/2014/main" id="{E013166A-97C0-458D-801F-51362263C086}"/>
+              </a:ext>
+            </a:extLst>
+          </p:cNvPr>
+          <p:cNvSpPr>
+            <a:spLocks xmlns:a="http://schemas.openxmlformats.org/drawingml/2006/main" noGrp="1"/>
+          </p:cNvSpPr>
+          <p:nvPr/>
+        </p:nvSpPr>
+        <p:spPr>
+          <a:xfrm xmlns:a="http://schemas.openxmlformats.org/drawingml/2006/main">
+            <a:off x="11725275" y="609600"/>
+            <a:ext cx="9525" cy="5753100"/>
+          </a:xfrm>
+          <a:prstGeom xmlns:a="http://schemas.openxmlformats.org/drawingml/2006/main" prst="rect">
+            <a:avLst/>
+          </a:prstGeom>
+          <a:solidFill xmlns:a="http://schemas.openxmlformats.org/drawingml/2006/main">
+            <a:srgbClr val="262626"/>
+          </a:solidFill>
+          <a:ln xmlns:a="http://schemas.openxmlformats.org/drawingml/2006/main" w="0">
+            <a:solidFill>
+              <a:srgbClr val="262626"/>
+            </a:solidFill>
+            <a:prstDash val="solid"/>
+          </a:ln>
+        </p:spPr>
+      </p:sp>
+      <p:sp>
+        <p:nvSpPr>
+          <p:cNvPr id="7" name="bottom-rule-2">
+            <a:extLst xmlns:a="http://schemas.openxmlformats.org/drawingml/2006/main">
+              <a:ext uri="{FF2B5EF4-FFF2-40B4-BE49-F238E27FC236}">
+                <a16:creationId xmlns:a16="http://schemas.microsoft.com/office/drawing/2014/main" id="{FD468988-D43A-4DA5-848C-68C40B451AD8}"/>
+              </a:ext>
+            </a:extLst>
+          </p:cNvPr>
+          <p:cNvSpPr>
+            <a:spLocks xmlns:a="http://schemas.openxmlformats.org/drawingml/2006/main" noGrp="1"/>
+          </p:cNvSpPr>
+          <p:nvPr/>
+        </p:nvSpPr>
+        <p:spPr>
+          <a:xfrm xmlns:a="http://schemas.openxmlformats.org/drawingml/2006/main">
+            <a:off x="457200" y="6362700"/>
+            <a:ext cx="11277600" cy="9525"/>
+          </a:xfrm>
+          <a:prstGeom xmlns:a="http://schemas.openxmlformats.org/drawingml/2006/main" prst="rect">
+            <a:avLst/>
+          </a:prstGeom>
+          <a:solidFill xmlns:a="http://schemas.openxmlformats.org/drawingml/2006/main">
+            <a:srgbClr val="262626"/>
+          </a:solidFill>
+          <a:ln xmlns:a="http://schemas.openxmlformats.org/drawingml/2006/main" w="0">
+            <a:solidFill>
+              <a:srgbClr val="262626"/>
+            </a:solidFill>
+            <a:prstDash val="solid"/>
+          </a:ln>
+        </p:spPr>
+      </p:sp>
+      <p:sp>
+        <p:nvSpPr>
+          <p:cNvPr id="8" name="page-2">
+            <a:extLst xmlns:a="http://schemas.openxmlformats.org/drawingml/2006/main">
+              <a:ext uri="{FF2B5EF4-FFF2-40B4-BE49-F238E27FC236}">
+                <a16:creationId xmlns:a16="http://schemas.microsoft.com/office/drawing/2014/main" id="{AD8098AA-5BFF-4CFF-BADE-8E8EAB2EF332}"/>
+              </a:ext>
+            </a:extLst>
+          </p:cNvPr>
+          <p:cNvSpPr>
+            <a:spLocks xmlns:a="http://schemas.openxmlformats.org/drawingml/2006/main" noGrp="1"/>
+          </p:cNvSpPr>
+          <p:nvPr/>
+        </p:nvSpPr>
+        <p:spPr>
+          <a:xfrm xmlns:a="http://schemas.openxmlformats.org/drawingml/2006/main">
+            <a:off x="11220450" y="6496050"/>
+            <a:ext cx="514350" cy="209550"/>
           </a:xfrm>
           <a:prstGeom xmlns:a="http://schemas.openxmlformats.org/drawingml/2006/main" prst="rect">
             <a:avLst/>
@@ -1608,9 +1773,9 @@
           <a:p xmlns:a="http://schemas.openxmlformats.org/drawingml/2006/main">
             <a:pPr algn="r">
               <a:buNone/>
-              <a:defRPr sz="1125" b="0">
-                <a:solidFill>
-                  <a:srgbClr val="A1A1A1"/>
+              <a:defRPr sz="975" b="0">
+                <a:solidFill>
+                  <a:srgbClr val="666666"/>
                 </a:solidFill>
                 <a:latin typeface="Arial"/>
                 <a:ea typeface="Arial"/>
@@ -1618,202 +1783,37 @@
               </a:defRPr>
             </a:pPr>
             <a:r>
-              <a:rPr sz="1125" b="0">
-                <a:solidFill>
-                  <a:srgbClr val="A1A1A1"/>
+              <a:rPr sz="975" b="0">
+                <a:solidFill>
+                  <a:srgbClr val="666666"/>
                 </a:solidFill>
                 <a:latin typeface="Arial"/>
                 <a:ea typeface="Arial"/>
                 <a:cs typeface="Arial"/>
               </a:rPr>
-              <a:t>ACU / ROUND 2</a:t>
+              <a:t>01</a:t>
             </a:r>
           </a:p>
         </p:txBody>
       </p:sp>
       <p:sp>
         <p:nvSpPr>
-          <p:cNvPr id="3" name="top-rule-2">
-            <a:extLst xmlns:a="http://schemas.openxmlformats.org/drawingml/2006/main">
-              <a:ext uri="{FF2B5EF4-FFF2-40B4-BE49-F238E27FC236}">
-                <a16:creationId xmlns:a16="http://schemas.microsoft.com/office/drawing/2014/main" id="{396DF957-A8C7-49AC-BAE3-958FDBC5C4E6}"/>
-              </a:ext>
-            </a:extLst>
-          </p:cNvPr>
-          <p:cNvSpPr>
-            <a:spLocks xmlns:a="http://schemas.openxmlformats.org/drawingml/2006/main" noGrp="1"/>
-          </p:cNvSpPr>
-          <p:nvPr/>
-        </p:nvSpPr>
-        <p:spPr>
-          <a:xfrm xmlns:a="http://schemas.openxmlformats.org/drawingml/2006/main">
-            <a:off x="457200" y="609600"/>
-            <a:ext cx="11277600" cy="9525"/>
-          </a:xfrm>
-          <a:prstGeom xmlns:a="http://schemas.openxmlformats.org/drawingml/2006/main" prst="rect">
-            <a:avLst/>
-          </a:prstGeom>
-          <a:solidFill xmlns:a="http://schemas.openxmlformats.org/drawingml/2006/main">
-            <a:srgbClr val="262626"/>
-          </a:solidFill>
-          <a:ln xmlns:a="http://schemas.openxmlformats.org/drawingml/2006/main" w="0">
-            <a:solidFill>
-              <a:srgbClr val="262626"/>
-            </a:solidFill>
-            <a:prstDash val="solid"/>
-          </a:ln>
-        </p:spPr>
-      </p:sp>
-      <p:sp>
-        <p:nvSpPr>
-          <p:cNvPr id="4" name="left-grid-2">
-            <a:extLst xmlns:a="http://schemas.openxmlformats.org/drawingml/2006/main">
-              <a:ext uri="{FF2B5EF4-FFF2-40B4-BE49-F238E27FC236}">
-                <a16:creationId xmlns:a16="http://schemas.microsoft.com/office/drawing/2014/main" id="{8D51CE1C-3BF4-46F9-A35E-65FE60844823}"/>
-              </a:ext>
-            </a:extLst>
-          </p:cNvPr>
-          <p:cNvSpPr>
-            <a:spLocks xmlns:a="http://schemas.openxmlformats.org/drawingml/2006/main" noGrp="1"/>
-          </p:cNvSpPr>
-          <p:nvPr/>
-        </p:nvSpPr>
-        <p:spPr>
-          <a:xfrm xmlns:a="http://schemas.openxmlformats.org/drawingml/2006/main">
-            <a:off x="457200" y="609600"/>
-            <a:ext cx="9525" cy="5753100"/>
-          </a:xfrm>
-          <a:prstGeom xmlns:a="http://schemas.openxmlformats.org/drawingml/2006/main" prst="rect">
-            <a:avLst/>
-          </a:prstGeom>
-          <a:solidFill xmlns:a="http://schemas.openxmlformats.org/drawingml/2006/main">
-            <a:srgbClr val="262626"/>
-          </a:solidFill>
-          <a:ln xmlns:a="http://schemas.openxmlformats.org/drawingml/2006/main" w="0">
-            <a:solidFill>
-              <a:srgbClr val="262626"/>
-            </a:solidFill>
-            <a:prstDash val="solid"/>
-          </a:ln>
-        </p:spPr>
-      </p:sp>
-      <p:sp>
-        <p:nvSpPr>
-          <p:cNvPr id="5" name="center-grid-2">
-            <a:extLst xmlns:a="http://schemas.openxmlformats.org/drawingml/2006/main">
-              <a:ext uri="{FF2B5EF4-FFF2-40B4-BE49-F238E27FC236}">
-                <a16:creationId xmlns:a16="http://schemas.microsoft.com/office/drawing/2014/main" id="{F3A88BBC-ECA8-430A-AAC3-873FA03A4391}"/>
-              </a:ext>
-            </a:extLst>
-          </p:cNvPr>
-          <p:cNvSpPr>
-            <a:spLocks xmlns:a="http://schemas.openxmlformats.org/drawingml/2006/main" noGrp="1"/>
-          </p:cNvSpPr>
-          <p:nvPr/>
-        </p:nvSpPr>
-        <p:spPr>
-          <a:xfrm xmlns:a="http://schemas.openxmlformats.org/drawingml/2006/main">
-            <a:off x="6096000" y="609600"/>
-            <a:ext cx="9525" cy="5753100"/>
-          </a:xfrm>
-          <a:prstGeom xmlns:a="http://schemas.openxmlformats.org/drawingml/2006/main" prst="rect">
-            <a:avLst/>
-          </a:prstGeom>
-          <a:solidFill xmlns:a="http://schemas.openxmlformats.org/drawingml/2006/main">
-            <a:srgbClr val="262626"/>
-          </a:solidFill>
-          <a:ln xmlns:a="http://schemas.openxmlformats.org/drawingml/2006/main" w="0">
-            <a:solidFill>
-              <a:srgbClr val="262626"/>
-            </a:solidFill>
-            <a:prstDash val="solid"/>
-          </a:ln>
-        </p:spPr>
-      </p:sp>
-      <p:sp>
-        <p:nvSpPr>
-          <p:cNvPr id="6" name="right-grid-2">
-            <a:extLst xmlns:a="http://schemas.openxmlformats.org/drawingml/2006/main">
-              <a:ext uri="{FF2B5EF4-FFF2-40B4-BE49-F238E27FC236}">
-                <a16:creationId xmlns:a16="http://schemas.microsoft.com/office/drawing/2014/main" id="{E013166A-97C0-458D-801F-51362263C086}"/>
-              </a:ext>
-            </a:extLst>
-          </p:cNvPr>
-          <p:cNvSpPr>
-            <a:spLocks xmlns:a="http://schemas.openxmlformats.org/drawingml/2006/main" noGrp="1"/>
-          </p:cNvSpPr>
-          <p:nvPr/>
-        </p:nvSpPr>
-        <p:spPr>
-          <a:xfrm xmlns:a="http://schemas.openxmlformats.org/drawingml/2006/main">
-            <a:off x="11725275" y="609600"/>
-            <a:ext cx="9525" cy="5753100"/>
-          </a:xfrm>
-          <a:prstGeom xmlns:a="http://schemas.openxmlformats.org/drawingml/2006/main" prst="rect">
-            <a:avLst/>
-          </a:prstGeom>
-          <a:solidFill xmlns:a="http://schemas.openxmlformats.org/drawingml/2006/main">
-            <a:srgbClr val="262626"/>
-          </a:solidFill>
-          <a:ln xmlns:a="http://schemas.openxmlformats.org/drawingml/2006/main" w="0">
-            <a:solidFill>
-              <a:srgbClr val="262626"/>
-            </a:solidFill>
-            <a:prstDash val="solid"/>
-          </a:ln>
-        </p:spPr>
-      </p:sp>
-      <p:sp>
-        <p:nvSpPr>
-          <p:cNvPr id="7" name="bottom-rule-2">
-            <a:extLst xmlns:a="http://schemas.openxmlformats.org/drawingml/2006/main">
-              <a:ext uri="{FF2B5EF4-FFF2-40B4-BE49-F238E27FC236}">
-                <a16:creationId xmlns:a16="http://schemas.microsoft.com/office/drawing/2014/main" id="{FD468988-D43A-4DA5-848C-68C40B451AD8}"/>
-              </a:ext>
-            </a:extLst>
-          </p:cNvPr>
-          <p:cNvSpPr>
-            <a:spLocks xmlns:a="http://schemas.openxmlformats.org/drawingml/2006/main" noGrp="1"/>
-          </p:cNvSpPr>
-          <p:nvPr/>
-        </p:nvSpPr>
-        <p:spPr>
-          <a:xfrm xmlns:a="http://schemas.openxmlformats.org/drawingml/2006/main">
-            <a:off x="457200" y="6362700"/>
-            <a:ext cx="11277600" cy="9525"/>
-          </a:xfrm>
-          <a:prstGeom xmlns:a="http://schemas.openxmlformats.org/drawingml/2006/main" prst="rect">
-            <a:avLst/>
-          </a:prstGeom>
-          <a:solidFill xmlns:a="http://schemas.openxmlformats.org/drawingml/2006/main">
-            <a:srgbClr val="262626"/>
-          </a:solidFill>
-          <a:ln xmlns:a="http://schemas.openxmlformats.org/drawingml/2006/main" w="0">
-            <a:solidFill>
-              <a:srgbClr val="262626"/>
-            </a:solidFill>
-            <a:prstDash val="solid"/>
-          </a:ln>
-        </p:spPr>
-      </p:sp>
-      <p:sp>
-        <p:nvSpPr>
-          <p:cNvPr id="8" name="page-2">
-            <a:extLst xmlns:a="http://schemas.openxmlformats.org/drawingml/2006/main">
-              <a:ext uri="{FF2B5EF4-FFF2-40B4-BE49-F238E27FC236}">
-                <a16:creationId xmlns:a16="http://schemas.microsoft.com/office/drawing/2014/main" id="{AD8098AA-5BFF-4CFF-BADE-8E8EAB2EF332}"/>
-              </a:ext>
-            </a:extLst>
-          </p:cNvPr>
-          <p:cNvSpPr>
-            <a:spLocks xmlns:a="http://schemas.openxmlformats.org/drawingml/2006/main" noGrp="1"/>
-          </p:cNvSpPr>
-          <p:nvPr/>
-        </p:nvSpPr>
-        <p:spPr>
-          <a:xfrm xmlns:a="http://schemas.openxmlformats.org/drawingml/2006/main">
-            <a:off x="11220450" y="6496050"/>
-            <a:ext cx="514350" cy="209550"/>
+          <p:cNvPr id="9" name="problem-title">
+            <a:extLst xmlns:a="http://schemas.openxmlformats.org/drawingml/2006/main">
+              <a:ext uri="{FF2B5EF4-FFF2-40B4-BE49-F238E27FC236}">
+                <a16:creationId xmlns:a16="http://schemas.microsoft.com/office/drawing/2014/main" id="{390833B5-6799-4CB3-BD3F-4801ADE1A9CF}"/>
+              </a:ext>
+            </a:extLst>
+          </p:cNvPr>
+          <p:cNvSpPr>
+            <a:spLocks xmlns:a="http://schemas.openxmlformats.org/drawingml/2006/main" noGrp="1"/>
+          </p:cNvSpPr>
+          <p:nvPr/>
+        </p:nvSpPr>
+        <p:spPr>
+          <a:xfrm xmlns:a="http://schemas.openxmlformats.org/drawingml/2006/main">
+            <a:off x="762000" y="1066800"/>
+            <a:ext cx="5048250" cy="1428750"/>
           </a:xfrm>
           <a:prstGeom xmlns:a="http://schemas.openxmlformats.org/drawingml/2006/main" prst="rect">
             <a:avLst/>
@@ -1830,11 +1830,11 @@
           </a:bodyPr>
           <a:lstStyle xmlns:a="http://schemas.openxmlformats.org/drawingml/2006/main"/>
           <a:p xmlns:a="http://schemas.openxmlformats.org/drawingml/2006/main">
-            <a:pPr algn="r">
+            <a:pPr algn="l">
               <a:buNone/>
-              <a:defRPr sz="975" b="0">
-                <a:solidFill>
-                  <a:srgbClr val="666666"/>
+              <a:defRPr sz="3900" b="1">
+                <a:solidFill>
+                  <a:srgbClr val="FFFFFF"/>
                 </a:solidFill>
                 <a:latin typeface="Arial"/>
                 <a:ea typeface="Arial"/>
@@ -1842,37 +1842,61 @@
               </a:defRPr>
             </a:pPr>
             <a:r>
-              <a:rPr sz="975" b="0">
-                <a:solidFill>
-                  <a:srgbClr val="666666"/>
+              <a:rPr sz="3900" b="1">
+                <a:solidFill>
+                  <a:srgbClr val="FFFFFF"/>
                 </a:solidFill>
                 <a:latin typeface="Arial"/>
                 <a:ea typeface="Arial"/>
                 <a:cs typeface="Arial"/>
               </a:rPr>
-              <a:t>01</a:t>
+              <a:t>At 1:47 a.m.,</a:t>
+            </a:r>
+          </a:p>
+          <a:p xmlns:a="http://schemas.openxmlformats.org/drawingml/2006/main">
+            <a:pPr algn="l">
+              <a:buNone/>
+              <a:defRPr sz="3900" b="1">
+                <a:solidFill>
+                  <a:srgbClr val="FFFFFF"/>
+                </a:solidFill>
+                <a:latin typeface="Arial"/>
+                <a:ea typeface="Arial"/>
+                <a:cs typeface="Arial"/>
+              </a:defRPr>
+            </a:pPr>
+            <a:r>
+              <a:rPr sz="3900" b="1">
+                <a:solidFill>
+                  <a:srgbClr val="FFFFFF"/>
+                </a:solidFill>
+                <a:latin typeface="Arial"/>
+                <a:ea typeface="Arial"/>
+                <a:cs typeface="Arial"/>
+              </a:rPr>
+              <a:t>Maya says it out loud.</a:t>
             </a:r>
           </a:p>
         </p:txBody>
       </p:sp>
       <p:sp>
         <p:nvSpPr>
-          <p:cNvPr id="9" name="problem-title">
-            <a:extLst xmlns:a="http://schemas.openxmlformats.org/drawingml/2006/main">
-              <a:ext uri="{FF2B5EF4-FFF2-40B4-BE49-F238E27FC236}">
-                <a16:creationId xmlns:a16="http://schemas.microsoft.com/office/drawing/2014/main" id="{390833B5-6799-4CB3-BD3F-4801ADE1A9CF}"/>
-              </a:ext>
-            </a:extLst>
-          </p:cNvPr>
-          <p:cNvSpPr>
-            <a:spLocks xmlns:a="http://schemas.openxmlformats.org/drawingml/2006/main" noGrp="1"/>
-          </p:cNvSpPr>
-          <p:nvPr/>
-        </p:nvSpPr>
-        <p:spPr>
-          <a:xfrm xmlns:a="http://schemas.openxmlformats.org/drawingml/2006/main">
-            <a:off x="762000" y="1066800"/>
-            <a:ext cx="5048250" cy="1428750"/>
+          <p:cNvPr id="10" name="problem-copy">
+            <a:extLst xmlns:a="http://schemas.openxmlformats.org/drawingml/2006/main">
+              <a:ext uri="{FF2B5EF4-FFF2-40B4-BE49-F238E27FC236}">
+                <a16:creationId xmlns:a16="http://schemas.microsoft.com/office/drawing/2014/main" id="{C93228B2-61C2-4642-A861-4D67789C6968}"/>
+              </a:ext>
+            </a:extLst>
+          </p:cNvPr>
+          <p:cNvSpPr>
+            <a:spLocks xmlns:a="http://schemas.openxmlformats.org/drawingml/2006/main" noGrp="1"/>
+          </p:cNvSpPr>
+          <p:nvPr/>
+        </p:nvSpPr>
+        <p:spPr>
+          <a:xfrm xmlns:a="http://schemas.openxmlformats.org/drawingml/2006/main">
+            <a:off x="762000" y="3162300"/>
+            <a:ext cx="4476750" cy="1028700"/>
           </a:xfrm>
           <a:prstGeom xmlns:a="http://schemas.openxmlformats.org/drawingml/2006/main" prst="rect">
             <a:avLst/>
@@ -1891,9 +1915,9 @@
           <a:p xmlns:a="http://schemas.openxmlformats.org/drawingml/2006/main">
             <a:pPr algn="l">
               <a:buNone/>
-              <a:defRPr sz="3900" b="1">
-                <a:solidFill>
-                  <a:srgbClr val="FFFFFF"/>
+              <a:defRPr sz="2100" b="0">
+                <a:solidFill>
+                  <a:srgbClr val="EDEDED"/>
                 </a:solidFill>
                 <a:latin typeface="Arial"/>
                 <a:ea typeface="Arial"/>
@@ -1901,23 +1925,23 @@
               </a:defRPr>
             </a:pPr>
             <a:r>
-              <a:rPr sz="3900" b="1">
-                <a:solidFill>
-                  <a:srgbClr val="FFFFFF"/>
+              <a:rPr sz="2100" b="0">
+                <a:solidFill>
+                  <a:srgbClr val="EDEDED"/>
                 </a:solidFill>
                 <a:latin typeface="Arial"/>
                 <a:ea typeface="Arial"/>
                 <a:cs typeface="Arial"/>
               </a:rPr>
-              <a:t>At 1:47 a.m.,</a:t>
+              <a:t>The move. The breakup.</a:t>
             </a:r>
           </a:p>
           <a:p xmlns:a="http://schemas.openxmlformats.org/drawingml/2006/main">
             <a:pPr algn="l">
               <a:buNone/>
-              <a:defRPr sz="3900" b="1">
-                <a:solidFill>
-                  <a:srgbClr val="FFFFFF"/>
+              <a:defRPr sz="2100" b="0">
+                <a:solidFill>
+                  <a:srgbClr val="EDEDED"/>
                 </a:solidFill>
                 <a:latin typeface="Arial"/>
                 <a:ea typeface="Arial"/>
@@ -1925,37 +1949,70 @@
               </a:defRPr>
             </a:pPr>
             <a:r>
-              <a:rPr sz="3900" b="1">
-                <a:solidFill>
-                  <a:srgbClr val="FFFFFF"/>
+              <a:rPr sz="2100" b="0">
+                <a:solidFill>
+                  <a:srgbClr val="EDEDED"/>
                 </a:solidFill>
                 <a:latin typeface="Arial"/>
                 <a:ea typeface="Arial"/>
                 <a:cs typeface="Arial"/>
               </a:rPr>
-              <a:t>Maya says it out loud.</a:t>
+              <a:t>The panic she hides at work.</a:t>
             </a:r>
           </a:p>
         </p:txBody>
       </p:sp>
       <p:sp>
         <p:nvSpPr>
-          <p:cNvPr id="10" name="problem-copy">
-            <a:extLst xmlns:a="http://schemas.openxmlformats.org/drawingml/2006/main">
-              <a:ext uri="{FF2B5EF4-FFF2-40B4-BE49-F238E27FC236}">
-                <a16:creationId xmlns:a16="http://schemas.microsoft.com/office/drawing/2014/main" id="{C93228B2-61C2-4642-A861-4D67789C6968}"/>
-              </a:ext>
-            </a:extLst>
-          </p:cNvPr>
-          <p:cNvSpPr>
-            <a:spLocks xmlns:a="http://schemas.openxmlformats.org/drawingml/2006/main" noGrp="1"/>
-          </p:cNvSpPr>
-          <p:nvPr/>
-        </p:nvSpPr>
-        <p:spPr>
-          <a:xfrm xmlns:a="http://schemas.openxmlformats.org/drawingml/2006/main">
-            <a:off x="762000" y="3162300"/>
-            <a:ext cx="4476750" cy="1028700"/>
+          <p:cNvPr id="11" name="problem-accent">
+            <a:extLst xmlns:a="http://schemas.openxmlformats.org/drawingml/2006/main">
+              <a:ext uri="{FF2B5EF4-FFF2-40B4-BE49-F238E27FC236}">
+                <a16:creationId xmlns:a16="http://schemas.microsoft.com/office/drawing/2014/main" id="{6DD737C0-34FA-4C70-B21E-3B58E969BB11}"/>
+              </a:ext>
+            </a:extLst>
+          </p:cNvPr>
+          <p:cNvSpPr>
+            <a:spLocks xmlns:a="http://schemas.openxmlformats.org/drawingml/2006/main" noGrp="1"/>
+          </p:cNvSpPr>
+          <p:nvPr/>
+        </p:nvSpPr>
+        <p:spPr>
+          <a:xfrm xmlns:a="http://schemas.openxmlformats.org/drawingml/2006/main">
+            <a:off x="762000" y="4629150"/>
+            <a:ext cx="609600" cy="28575"/>
+          </a:xfrm>
+          <a:prstGeom xmlns:a="http://schemas.openxmlformats.org/drawingml/2006/main" prst="rect">
+            <a:avLst/>
+          </a:prstGeom>
+          <a:solidFill xmlns:a="http://schemas.openxmlformats.org/drawingml/2006/main">
+            <a:srgbClr val="65D49A"/>
+          </a:solidFill>
+          <a:ln xmlns:a="http://schemas.openxmlformats.org/drawingml/2006/main" w="0">
+            <a:solidFill>
+              <a:srgbClr val="65D49A"/>
+            </a:solidFill>
+            <a:prstDash val="solid"/>
+          </a:ln>
+        </p:spPr>
+      </p:sp>
+      <p:sp>
+        <p:nvSpPr>
+          <p:cNvPr id="12" name="problem-outcome">
+            <a:extLst xmlns:a="http://schemas.openxmlformats.org/drawingml/2006/main">
+              <a:ext uri="{FF2B5EF4-FFF2-40B4-BE49-F238E27FC236}">
+                <a16:creationId xmlns:a16="http://schemas.microsoft.com/office/drawing/2014/main" id="{B982973F-769C-4B15-99A5-B9F852FE763C}"/>
+              </a:ext>
+            </a:extLst>
+          </p:cNvPr>
+          <p:cNvSpPr>
+            <a:spLocks xmlns:a="http://schemas.openxmlformats.org/drawingml/2006/main" noGrp="1"/>
+          </p:cNvSpPr>
+          <p:nvPr/>
+        </p:nvSpPr>
+        <p:spPr>
+          <a:xfrm xmlns:a="http://schemas.openxmlformats.org/drawingml/2006/main">
+            <a:off x="762000" y="4895850"/>
+            <a:ext cx="4572000" cy="800100"/>
           </a:xfrm>
           <a:prstGeom xmlns:a="http://schemas.openxmlformats.org/drawingml/2006/main" prst="rect">
             <a:avLst/>
@@ -1974,9 +2031,9 @@
           <a:p xmlns:a="http://schemas.openxmlformats.org/drawingml/2006/main">
             <a:pPr algn="l">
               <a:buNone/>
-              <a:defRPr sz="2100" b="0">
-                <a:solidFill>
-                  <a:srgbClr val="EDEDED"/>
+              <a:defRPr sz="1575" b="0">
+                <a:solidFill>
+                  <a:srgbClr val="A1A1A1"/>
                 </a:solidFill>
                 <a:latin typeface="Arial"/>
                 <a:ea typeface="Arial"/>
@@ -1984,109 +2041,17 @@
               </a:defRPr>
             </a:pPr>
             <a:r>
-              <a:rPr sz="2100" b="0">
-                <a:solidFill>
-                  <a:srgbClr val="EDEDED"/>
+              <a:rPr sz="1575" b="0">
+                <a:solidFill>
+                  <a:srgbClr val="A1A1A1"/>
                 </a:solidFill>
                 <a:latin typeface="Arial"/>
                 <a:ea typeface="Arial"/>
                 <a:cs typeface="Arial"/>
               </a:rPr>
-              <a:t>The move. The breakup.</a:t>
-            </a:r>
-          </a:p>
-          <a:p xmlns:a="http://schemas.openxmlformats.org/drawingml/2006/main">
-            <a:pPr algn="l">
-              <a:buNone/>
-              <a:defRPr sz="2100" b="0">
-                <a:solidFill>
-                  <a:srgbClr val="EDEDED"/>
-                </a:solidFill>
-                <a:latin typeface="Arial"/>
-                <a:ea typeface="Arial"/>
-                <a:cs typeface="Arial"/>
-              </a:defRPr>
-            </a:pPr>
-            <a:r>
-              <a:rPr sz="2100" b="0">
-                <a:solidFill>
-                  <a:srgbClr val="EDEDED"/>
-                </a:solidFill>
-                <a:latin typeface="Arial"/>
-                <a:ea typeface="Arial"/>
-                <a:cs typeface="Arial"/>
-              </a:rPr>
-              <a:t>The panic she hides at work.</a:t>
-            </a:r>
-          </a:p>
-        </p:txBody>
-      </p:sp>
-      <p:sp>
-        <p:nvSpPr>
-          <p:cNvPr id="11" name="problem-accent">
-            <a:extLst xmlns:a="http://schemas.openxmlformats.org/drawingml/2006/main">
-              <a:ext uri="{FF2B5EF4-FFF2-40B4-BE49-F238E27FC236}">
-                <a16:creationId xmlns:a16="http://schemas.microsoft.com/office/drawing/2014/main" id="{6DD737C0-34FA-4C70-B21E-3B58E969BB11}"/>
-              </a:ext>
-            </a:extLst>
-          </p:cNvPr>
-          <p:cNvSpPr>
-            <a:spLocks xmlns:a="http://schemas.openxmlformats.org/drawingml/2006/main" noGrp="1"/>
-          </p:cNvSpPr>
-          <p:nvPr/>
-        </p:nvSpPr>
-        <p:spPr>
-          <a:xfrm xmlns:a="http://schemas.openxmlformats.org/drawingml/2006/main">
-            <a:off x="762000" y="4629150"/>
-            <a:ext cx="609600" cy="28575"/>
-          </a:xfrm>
-          <a:prstGeom xmlns:a="http://schemas.openxmlformats.org/drawingml/2006/main" prst="rect">
-            <a:avLst/>
-          </a:prstGeom>
-          <a:solidFill xmlns:a="http://schemas.openxmlformats.org/drawingml/2006/main">
-            <a:srgbClr val="65D49A"/>
-          </a:solidFill>
-          <a:ln xmlns:a="http://schemas.openxmlformats.org/drawingml/2006/main" w="0">
-            <a:solidFill>
-              <a:srgbClr val="65D49A"/>
-            </a:solidFill>
-            <a:prstDash val="solid"/>
-          </a:ln>
-        </p:spPr>
-      </p:sp>
-      <p:sp>
-        <p:nvSpPr>
-          <p:cNvPr id="12" name="problem-outcome">
-            <a:extLst xmlns:a="http://schemas.openxmlformats.org/drawingml/2006/main">
-              <a:ext uri="{FF2B5EF4-FFF2-40B4-BE49-F238E27FC236}">
-                <a16:creationId xmlns:a16="http://schemas.microsoft.com/office/drawing/2014/main" id="{B982973F-769C-4B15-99A5-B9F852FE763C}"/>
-              </a:ext>
-            </a:extLst>
-          </p:cNvPr>
-          <p:cNvSpPr>
-            <a:spLocks xmlns:a="http://schemas.openxmlformats.org/drawingml/2006/main" noGrp="1"/>
-          </p:cNvSpPr>
-          <p:nvPr/>
-        </p:nvSpPr>
-        <p:spPr>
-          <a:xfrm xmlns:a="http://schemas.openxmlformats.org/drawingml/2006/main">
-            <a:off x="762000" y="4895850"/>
-            <a:ext cx="4572000" cy="800100"/>
-          </a:xfrm>
-          <a:prstGeom xmlns:a="http://schemas.openxmlformats.org/drawingml/2006/main" prst="rect">
-            <a:avLst/>
-          </a:prstGeom>
-          <a:noFill xmlns:a="http://schemas.openxmlformats.org/drawingml/2006/main"/>
-          <a:ln xmlns:a="http://schemas.openxmlformats.org/drawingml/2006/main" w="0">
-            <a:noFill/>
-            <a:prstDash val="solid"/>
-          </a:ln>
-        </p:spPr>
-        <p:txBody>
-          <a:bodyPr xmlns:a="http://schemas.openxmlformats.org/drawingml/2006/main" wrap="square" lIns="0" tIns="0" rIns="0" bIns="0" anchor="t">
-            <a:noAutofit/>
-          </a:bodyPr>
-          <a:lstStyle xmlns:a="http://schemas.openxmlformats.org/drawingml/2006/main"/>
+              <a:t>The AI listens.</a:t>
+            </a:r>
+          </a:p>
           <a:p xmlns:a="http://schemas.openxmlformats.org/drawingml/2006/main">
             <a:pPr algn="l">
               <a:buNone/>
@@ -2108,30 +2073,6 @@
                 <a:ea typeface="Arial"/>
                 <a:cs typeface="Arial"/>
               </a:rPr>
-              <a:t>The AI listens.</a:t>
-            </a:r>
-          </a:p>
-          <a:p xmlns:a="http://schemas.openxmlformats.org/drawingml/2006/main">
-            <a:pPr algn="l">
-              <a:buNone/>
-              <a:defRPr sz="1575" b="0">
-                <a:solidFill>
-                  <a:srgbClr val="A1A1A1"/>
-                </a:solidFill>
-                <a:latin typeface="Arial"/>
-                <a:ea typeface="Arial"/>
-                <a:cs typeface="Arial"/>
-              </a:defRPr>
-            </a:pPr>
-            <a:r>
-              <a:rPr sz="1575" b="0">
-                <a:solidFill>
-                  <a:srgbClr val="A1A1A1"/>
-                </a:solidFill>
-                <a:latin typeface="Arial"/>
-                <a:ea typeface="Arial"/>
-                <a:cs typeface="Arial"/>
-              </a:rPr>
               <a:t>Then Maya closes the app.</a:t>
             </a:r>
           </a:p>
@@ -2139,14 +2080,14 @@
       </p:sp>
       <p:pic>
         <p:nvPicPr>
-          <p:cNvPr id="29" name=""/>
+          <p:cNvPr id="28" name=""/>
           <p:cNvPicPr>
             <a:picLocks xmlns:a="http://schemas.openxmlformats.org/drawingml/2006/main" noChangeAspect="1"/>
           </p:cNvPicPr>
           <p:nvPr/>
         </p:nvPicPr>
         <p:blipFill>
-          <a:blip xmlns:r="http://schemas.openxmlformats.org/officeDocument/2006/relationships" xmlns:a="http://schemas.openxmlformats.org/drawingml/2006/main" r:embed="R7ceb67db079f4fb9"/>
+          <a:blip xmlns:r="http://schemas.openxmlformats.org/officeDocument/2006/relationships" xmlns:a="http://schemas.openxmlformats.org/drawingml/2006/main" r:embed="R6b42f533a0bc4ba4"/>
           <a:srcRect xmlns:a="http://schemas.openxmlformats.org/drawingml/2006/main" l="22485" t="0" r="22485" b="0"/>
           <a:stretch xmlns:a="http://schemas.openxmlformats.org/drawingml/2006/main">
             <a:fillRect l="0" t="0" r="0" b="0"/>
@@ -2283,65 +2224,6 @@
       </p:sp>
       <p:sp>
         <p:nvSpPr>
-          <p:cNvPr id="2" name="round-1">
-            <a:extLst xmlns:a="http://schemas.openxmlformats.org/drawingml/2006/main">
-              <a:ext uri="{FF2B5EF4-FFF2-40B4-BE49-F238E27FC236}">
-                <a16:creationId xmlns:a16="http://schemas.microsoft.com/office/drawing/2014/main" id="{7619B49E-5D77-437A-8597-2E9CAD6278DE}"/>
-              </a:ext>
-            </a:extLst>
-          </p:cNvPr>
-          <p:cNvSpPr>
-            <a:spLocks xmlns:a="http://schemas.openxmlformats.org/drawingml/2006/main" noGrp="1"/>
-          </p:cNvSpPr>
-          <p:nvPr/>
-        </p:nvSpPr>
-        <p:spPr>
-          <a:xfrm xmlns:a="http://schemas.openxmlformats.org/drawingml/2006/main">
-            <a:off x="9334500" y="247650"/>
-            <a:ext cx="2400300" cy="247650"/>
-          </a:xfrm>
-          <a:prstGeom xmlns:a="http://schemas.openxmlformats.org/drawingml/2006/main" prst="rect">
-            <a:avLst/>
-          </a:prstGeom>
-          <a:noFill xmlns:a="http://schemas.openxmlformats.org/drawingml/2006/main"/>
-          <a:ln xmlns:a="http://schemas.openxmlformats.org/drawingml/2006/main" w="0">
-            <a:noFill/>
-            <a:prstDash val="solid"/>
-          </a:ln>
-        </p:spPr>
-        <p:txBody>
-          <a:bodyPr xmlns:a="http://schemas.openxmlformats.org/drawingml/2006/main" wrap="square" lIns="0" tIns="0" rIns="0" bIns="0" anchor="t">
-            <a:noAutofit/>
-          </a:bodyPr>
-          <a:lstStyle xmlns:a="http://schemas.openxmlformats.org/drawingml/2006/main"/>
-          <a:p xmlns:a="http://schemas.openxmlformats.org/drawingml/2006/main">
-            <a:pPr algn="r">
-              <a:buNone/>
-              <a:defRPr sz="1125" b="0">
-                <a:solidFill>
-                  <a:srgbClr val="A1A1A1"/>
-                </a:solidFill>
-                <a:latin typeface="Arial"/>
-                <a:ea typeface="Arial"/>
-                <a:cs typeface="Arial"/>
-              </a:defRPr>
-            </a:pPr>
-            <a:r>
-              <a:rPr sz="1125" b="0">
-                <a:solidFill>
-                  <a:srgbClr val="A1A1A1"/>
-                </a:solidFill>
-                <a:latin typeface="Arial"/>
-                <a:ea typeface="Arial"/>
-                <a:cs typeface="Arial"/>
-              </a:rPr>
-              <a:t>ACU / ROUND 2</a:t>
-            </a:r>
-          </a:p>
-        </p:txBody>
-      </p:sp>
-      <p:sp>
-        <p:nvSpPr>
           <p:cNvPr id="3" name="top-rule-1">
             <a:extLst xmlns:a="http://schemas.openxmlformats.org/drawingml/2006/main">
               <a:ext uri="{FF2B5EF4-FFF2-40B4-BE49-F238E27FC236}">
@@ -2903,22 +2785,187 @@
       </p:sp>
       <p:sp>
         <p:nvSpPr>
-          <p:cNvPr id="2" name="round-3">
-            <a:extLst xmlns:a="http://schemas.openxmlformats.org/drawingml/2006/main">
-              <a:ext uri="{FF2B5EF4-FFF2-40B4-BE49-F238E27FC236}">
-                <a16:creationId xmlns:a16="http://schemas.microsoft.com/office/drawing/2014/main" id="{E7FCCF19-3BBC-4053-99D0-86AC26755412}"/>
-              </a:ext>
-            </a:extLst>
-          </p:cNvPr>
-          <p:cNvSpPr>
-            <a:spLocks xmlns:a="http://schemas.openxmlformats.org/drawingml/2006/main" noGrp="1"/>
-          </p:cNvSpPr>
-          <p:nvPr/>
-        </p:nvSpPr>
-        <p:spPr>
-          <a:xfrm xmlns:a="http://schemas.openxmlformats.org/drawingml/2006/main">
-            <a:off x="9334500" y="247650"/>
-            <a:ext cx="2400300" cy="247650"/>
+          <p:cNvPr id="3" name="top-rule-3">
+            <a:extLst xmlns:a="http://schemas.openxmlformats.org/drawingml/2006/main">
+              <a:ext uri="{FF2B5EF4-FFF2-40B4-BE49-F238E27FC236}">
+                <a16:creationId xmlns:a16="http://schemas.microsoft.com/office/drawing/2014/main" id="{4624381B-2059-4CD7-9344-CA0DB3C8ED8B}"/>
+              </a:ext>
+            </a:extLst>
+          </p:cNvPr>
+          <p:cNvSpPr>
+            <a:spLocks xmlns:a="http://schemas.openxmlformats.org/drawingml/2006/main" noGrp="1"/>
+          </p:cNvSpPr>
+          <p:nvPr/>
+        </p:nvSpPr>
+        <p:spPr>
+          <a:xfrm xmlns:a="http://schemas.openxmlformats.org/drawingml/2006/main">
+            <a:off x="457200" y="609600"/>
+            <a:ext cx="11277600" cy="9525"/>
+          </a:xfrm>
+          <a:prstGeom xmlns:a="http://schemas.openxmlformats.org/drawingml/2006/main" prst="rect">
+            <a:avLst/>
+          </a:prstGeom>
+          <a:solidFill xmlns:a="http://schemas.openxmlformats.org/drawingml/2006/main">
+            <a:srgbClr val="262626"/>
+          </a:solidFill>
+          <a:ln xmlns:a="http://schemas.openxmlformats.org/drawingml/2006/main" w="0">
+            <a:solidFill>
+              <a:srgbClr val="262626"/>
+            </a:solidFill>
+            <a:prstDash val="solid"/>
+          </a:ln>
+        </p:spPr>
+      </p:sp>
+      <p:sp>
+        <p:nvSpPr>
+          <p:cNvPr id="4" name="left-grid-3">
+            <a:extLst xmlns:a="http://schemas.openxmlformats.org/drawingml/2006/main">
+              <a:ext uri="{FF2B5EF4-FFF2-40B4-BE49-F238E27FC236}">
+                <a16:creationId xmlns:a16="http://schemas.microsoft.com/office/drawing/2014/main" id="{11D7EE24-2E41-49DC-8821-C7FC5B1F7AD6}"/>
+              </a:ext>
+            </a:extLst>
+          </p:cNvPr>
+          <p:cNvSpPr>
+            <a:spLocks xmlns:a="http://schemas.openxmlformats.org/drawingml/2006/main" noGrp="1"/>
+          </p:cNvSpPr>
+          <p:nvPr/>
+        </p:nvSpPr>
+        <p:spPr>
+          <a:xfrm xmlns:a="http://schemas.openxmlformats.org/drawingml/2006/main">
+            <a:off x="457200" y="609600"/>
+            <a:ext cx="9525" cy="5753100"/>
+          </a:xfrm>
+          <a:prstGeom xmlns:a="http://schemas.openxmlformats.org/drawingml/2006/main" prst="rect">
+            <a:avLst/>
+          </a:prstGeom>
+          <a:solidFill xmlns:a="http://schemas.openxmlformats.org/drawingml/2006/main">
+            <a:srgbClr val="262626"/>
+          </a:solidFill>
+          <a:ln xmlns:a="http://schemas.openxmlformats.org/drawingml/2006/main" w="0">
+            <a:solidFill>
+              <a:srgbClr val="262626"/>
+            </a:solidFill>
+            <a:prstDash val="solid"/>
+          </a:ln>
+        </p:spPr>
+      </p:sp>
+      <p:sp>
+        <p:nvSpPr>
+          <p:cNvPr id="5" name="center-grid-3">
+            <a:extLst xmlns:a="http://schemas.openxmlformats.org/drawingml/2006/main">
+              <a:ext uri="{FF2B5EF4-FFF2-40B4-BE49-F238E27FC236}">
+                <a16:creationId xmlns:a16="http://schemas.microsoft.com/office/drawing/2014/main" id="{DA3B6609-3E62-47F4-911A-5EE8663BB7A4}"/>
+              </a:ext>
+            </a:extLst>
+          </p:cNvPr>
+          <p:cNvSpPr>
+            <a:spLocks xmlns:a="http://schemas.openxmlformats.org/drawingml/2006/main" noGrp="1"/>
+          </p:cNvSpPr>
+          <p:nvPr/>
+        </p:nvSpPr>
+        <p:spPr>
+          <a:xfrm xmlns:a="http://schemas.openxmlformats.org/drawingml/2006/main">
+            <a:off x="6096000" y="609600"/>
+            <a:ext cx="9525" cy="5753100"/>
+          </a:xfrm>
+          <a:prstGeom xmlns:a="http://schemas.openxmlformats.org/drawingml/2006/main" prst="rect">
+            <a:avLst/>
+          </a:prstGeom>
+          <a:solidFill xmlns:a="http://schemas.openxmlformats.org/drawingml/2006/main">
+            <a:srgbClr val="262626"/>
+          </a:solidFill>
+          <a:ln xmlns:a="http://schemas.openxmlformats.org/drawingml/2006/main" w="0">
+            <a:solidFill>
+              <a:srgbClr val="262626"/>
+            </a:solidFill>
+            <a:prstDash val="solid"/>
+          </a:ln>
+        </p:spPr>
+      </p:sp>
+      <p:sp>
+        <p:nvSpPr>
+          <p:cNvPr id="6" name="right-grid-3">
+            <a:extLst xmlns:a="http://schemas.openxmlformats.org/drawingml/2006/main">
+              <a:ext uri="{FF2B5EF4-FFF2-40B4-BE49-F238E27FC236}">
+                <a16:creationId xmlns:a16="http://schemas.microsoft.com/office/drawing/2014/main" id="{DB8383FF-1369-401B-98ED-D4CDFFDA0633}"/>
+              </a:ext>
+            </a:extLst>
+          </p:cNvPr>
+          <p:cNvSpPr>
+            <a:spLocks xmlns:a="http://schemas.openxmlformats.org/drawingml/2006/main" noGrp="1"/>
+          </p:cNvSpPr>
+          <p:nvPr/>
+        </p:nvSpPr>
+        <p:spPr>
+          <a:xfrm xmlns:a="http://schemas.openxmlformats.org/drawingml/2006/main">
+            <a:off x="11725275" y="609600"/>
+            <a:ext cx="9525" cy="5753100"/>
+          </a:xfrm>
+          <a:prstGeom xmlns:a="http://schemas.openxmlformats.org/drawingml/2006/main" prst="rect">
+            <a:avLst/>
+          </a:prstGeom>
+          <a:solidFill xmlns:a="http://schemas.openxmlformats.org/drawingml/2006/main">
+            <a:srgbClr val="262626"/>
+          </a:solidFill>
+          <a:ln xmlns:a="http://schemas.openxmlformats.org/drawingml/2006/main" w="0">
+            <a:solidFill>
+              <a:srgbClr val="262626"/>
+            </a:solidFill>
+            <a:prstDash val="solid"/>
+          </a:ln>
+        </p:spPr>
+      </p:sp>
+      <p:sp>
+        <p:nvSpPr>
+          <p:cNvPr id="7" name="bottom-rule-3">
+            <a:extLst xmlns:a="http://schemas.openxmlformats.org/drawingml/2006/main">
+              <a:ext uri="{FF2B5EF4-FFF2-40B4-BE49-F238E27FC236}">
+                <a16:creationId xmlns:a16="http://schemas.microsoft.com/office/drawing/2014/main" id="{B2E3F309-0E44-499C-9C14-73E7BCBF2215}"/>
+              </a:ext>
+            </a:extLst>
+          </p:cNvPr>
+          <p:cNvSpPr>
+            <a:spLocks xmlns:a="http://schemas.openxmlformats.org/drawingml/2006/main" noGrp="1"/>
+          </p:cNvSpPr>
+          <p:nvPr/>
+        </p:nvSpPr>
+        <p:spPr>
+          <a:xfrm xmlns:a="http://schemas.openxmlformats.org/drawingml/2006/main">
+            <a:off x="457200" y="6362700"/>
+            <a:ext cx="11277600" cy="9525"/>
+          </a:xfrm>
+          <a:prstGeom xmlns:a="http://schemas.openxmlformats.org/drawingml/2006/main" prst="rect">
+            <a:avLst/>
+          </a:prstGeom>
+          <a:solidFill xmlns:a="http://schemas.openxmlformats.org/drawingml/2006/main">
+            <a:srgbClr val="262626"/>
+          </a:solidFill>
+          <a:ln xmlns:a="http://schemas.openxmlformats.org/drawingml/2006/main" w="0">
+            <a:solidFill>
+              <a:srgbClr val="262626"/>
+            </a:solidFill>
+            <a:prstDash val="solid"/>
+          </a:ln>
+        </p:spPr>
+      </p:sp>
+      <p:sp>
+        <p:nvSpPr>
+          <p:cNvPr id="8" name="page-3">
+            <a:extLst xmlns:a="http://schemas.openxmlformats.org/drawingml/2006/main">
+              <a:ext uri="{FF2B5EF4-FFF2-40B4-BE49-F238E27FC236}">
+                <a16:creationId xmlns:a16="http://schemas.microsoft.com/office/drawing/2014/main" id="{8BA90A62-2127-45E6-BADA-F202A7D68752}"/>
+              </a:ext>
+            </a:extLst>
+          </p:cNvPr>
+          <p:cNvSpPr>
+            <a:spLocks xmlns:a="http://schemas.openxmlformats.org/drawingml/2006/main" noGrp="1"/>
+          </p:cNvSpPr>
+          <p:nvPr/>
+        </p:nvSpPr>
+        <p:spPr>
+          <a:xfrm xmlns:a="http://schemas.openxmlformats.org/drawingml/2006/main">
+            <a:off x="11220450" y="6496050"/>
+            <a:ext cx="514350" cy="209550"/>
           </a:xfrm>
           <a:prstGeom xmlns:a="http://schemas.openxmlformats.org/drawingml/2006/main" prst="rect">
             <a:avLst/>
@@ -2937,9 +2984,9 @@
           <a:p xmlns:a="http://schemas.openxmlformats.org/drawingml/2006/main">
             <a:pPr algn="r">
               <a:buNone/>
-              <a:defRPr sz="1125" b="0">
-                <a:solidFill>
-                  <a:srgbClr val="A1A1A1"/>
+              <a:defRPr sz="975" b="0">
+                <a:solidFill>
+                  <a:srgbClr val="666666"/>
                 </a:solidFill>
                 <a:latin typeface="Arial"/>
                 <a:ea typeface="Arial"/>
@@ -2947,202 +2994,37 @@
               </a:defRPr>
             </a:pPr>
             <a:r>
-              <a:rPr sz="1125" b="0">
-                <a:solidFill>
-                  <a:srgbClr val="A1A1A1"/>
+              <a:rPr sz="975" b="0">
+                <a:solidFill>
+                  <a:srgbClr val="666666"/>
                 </a:solidFill>
                 <a:latin typeface="Arial"/>
                 <a:ea typeface="Arial"/>
                 <a:cs typeface="Arial"/>
               </a:rPr>
-              <a:t>ACU / ROUND 2</a:t>
+              <a:t>03</a:t>
             </a:r>
           </a:p>
         </p:txBody>
       </p:sp>
       <p:sp>
         <p:nvSpPr>
-          <p:cNvPr id="3" name="top-rule-3">
-            <a:extLst xmlns:a="http://schemas.openxmlformats.org/drawingml/2006/main">
-              <a:ext uri="{FF2B5EF4-FFF2-40B4-BE49-F238E27FC236}">
-                <a16:creationId xmlns:a16="http://schemas.microsoft.com/office/drawing/2014/main" id="{4624381B-2059-4CD7-9344-CA0DB3C8ED8B}"/>
-              </a:ext>
-            </a:extLst>
-          </p:cNvPr>
-          <p:cNvSpPr>
-            <a:spLocks xmlns:a="http://schemas.openxmlformats.org/drawingml/2006/main" noGrp="1"/>
-          </p:cNvSpPr>
-          <p:nvPr/>
-        </p:nvSpPr>
-        <p:spPr>
-          <a:xfrm xmlns:a="http://schemas.openxmlformats.org/drawingml/2006/main">
-            <a:off x="457200" y="609600"/>
-            <a:ext cx="11277600" cy="9525"/>
-          </a:xfrm>
-          <a:prstGeom xmlns:a="http://schemas.openxmlformats.org/drawingml/2006/main" prst="rect">
-            <a:avLst/>
-          </a:prstGeom>
-          <a:solidFill xmlns:a="http://schemas.openxmlformats.org/drawingml/2006/main">
-            <a:srgbClr val="262626"/>
-          </a:solidFill>
-          <a:ln xmlns:a="http://schemas.openxmlformats.org/drawingml/2006/main" w="0">
-            <a:solidFill>
-              <a:srgbClr val="262626"/>
-            </a:solidFill>
-            <a:prstDash val="solid"/>
-          </a:ln>
-        </p:spPr>
-      </p:sp>
-      <p:sp>
-        <p:nvSpPr>
-          <p:cNvPr id="4" name="left-grid-3">
-            <a:extLst xmlns:a="http://schemas.openxmlformats.org/drawingml/2006/main">
-              <a:ext uri="{FF2B5EF4-FFF2-40B4-BE49-F238E27FC236}">
-                <a16:creationId xmlns:a16="http://schemas.microsoft.com/office/drawing/2014/main" id="{11D7EE24-2E41-49DC-8821-C7FC5B1F7AD6}"/>
-              </a:ext>
-            </a:extLst>
-          </p:cNvPr>
-          <p:cNvSpPr>
-            <a:spLocks xmlns:a="http://schemas.openxmlformats.org/drawingml/2006/main" noGrp="1"/>
-          </p:cNvSpPr>
-          <p:nvPr/>
-        </p:nvSpPr>
-        <p:spPr>
-          <a:xfrm xmlns:a="http://schemas.openxmlformats.org/drawingml/2006/main">
-            <a:off x="457200" y="609600"/>
-            <a:ext cx="9525" cy="5753100"/>
-          </a:xfrm>
-          <a:prstGeom xmlns:a="http://schemas.openxmlformats.org/drawingml/2006/main" prst="rect">
-            <a:avLst/>
-          </a:prstGeom>
-          <a:solidFill xmlns:a="http://schemas.openxmlformats.org/drawingml/2006/main">
-            <a:srgbClr val="262626"/>
-          </a:solidFill>
-          <a:ln xmlns:a="http://schemas.openxmlformats.org/drawingml/2006/main" w="0">
-            <a:solidFill>
-              <a:srgbClr val="262626"/>
-            </a:solidFill>
-            <a:prstDash val="solid"/>
-          </a:ln>
-        </p:spPr>
-      </p:sp>
-      <p:sp>
-        <p:nvSpPr>
-          <p:cNvPr id="5" name="center-grid-3">
-            <a:extLst xmlns:a="http://schemas.openxmlformats.org/drawingml/2006/main">
-              <a:ext uri="{FF2B5EF4-FFF2-40B4-BE49-F238E27FC236}">
-                <a16:creationId xmlns:a16="http://schemas.microsoft.com/office/drawing/2014/main" id="{DA3B6609-3E62-47F4-911A-5EE8663BB7A4}"/>
-              </a:ext>
-            </a:extLst>
-          </p:cNvPr>
-          <p:cNvSpPr>
-            <a:spLocks xmlns:a="http://schemas.openxmlformats.org/drawingml/2006/main" noGrp="1"/>
-          </p:cNvSpPr>
-          <p:nvPr/>
-        </p:nvSpPr>
-        <p:spPr>
-          <a:xfrm xmlns:a="http://schemas.openxmlformats.org/drawingml/2006/main">
-            <a:off x="6096000" y="609600"/>
-            <a:ext cx="9525" cy="5753100"/>
-          </a:xfrm>
-          <a:prstGeom xmlns:a="http://schemas.openxmlformats.org/drawingml/2006/main" prst="rect">
-            <a:avLst/>
-          </a:prstGeom>
-          <a:solidFill xmlns:a="http://schemas.openxmlformats.org/drawingml/2006/main">
-            <a:srgbClr val="262626"/>
-          </a:solidFill>
-          <a:ln xmlns:a="http://schemas.openxmlformats.org/drawingml/2006/main" w="0">
-            <a:solidFill>
-              <a:srgbClr val="262626"/>
-            </a:solidFill>
-            <a:prstDash val="solid"/>
-          </a:ln>
-        </p:spPr>
-      </p:sp>
-      <p:sp>
-        <p:nvSpPr>
-          <p:cNvPr id="6" name="right-grid-3">
-            <a:extLst xmlns:a="http://schemas.openxmlformats.org/drawingml/2006/main">
-              <a:ext uri="{FF2B5EF4-FFF2-40B4-BE49-F238E27FC236}">
-                <a16:creationId xmlns:a16="http://schemas.microsoft.com/office/drawing/2014/main" id="{DB8383FF-1369-401B-98ED-D4CDFFDA0633}"/>
-              </a:ext>
-            </a:extLst>
-          </p:cNvPr>
-          <p:cNvSpPr>
-            <a:spLocks xmlns:a="http://schemas.openxmlformats.org/drawingml/2006/main" noGrp="1"/>
-          </p:cNvSpPr>
-          <p:nvPr/>
-        </p:nvSpPr>
-        <p:spPr>
-          <a:xfrm xmlns:a="http://schemas.openxmlformats.org/drawingml/2006/main">
-            <a:off x="11725275" y="609600"/>
-            <a:ext cx="9525" cy="5753100"/>
-          </a:xfrm>
-          <a:prstGeom xmlns:a="http://schemas.openxmlformats.org/drawingml/2006/main" prst="rect">
-            <a:avLst/>
-          </a:prstGeom>
-          <a:solidFill xmlns:a="http://schemas.openxmlformats.org/drawingml/2006/main">
-            <a:srgbClr val="262626"/>
-          </a:solidFill>
-          <a:ln xmlns:a="http://schemas.openxmlformats.org/drawingml/2006/main" w="0">
-            <a:solidFill>
-              <a:srgbClr val="262626"/>
-            </a:solidFill>
-            <a:prstDash val="solid"/>
-          </a:ln>
-        </p:spPr>
-      </p:sp>
-      <p:sp>
-        <p:nvSpPr>
-          <p:cNvPr id="7" name="bottom-rule-3">
-            <a:extLst xmlns:a="http://schemas.openxmlformats.org/drawingml/2006/main">
-              <a:ext uri="{FF2B5EF4-FFF2-40B4-BE49-F238E27FC236}">
-                <a16:creationId xmlns:a16="http://schemas.microsoft.com/office/drawing/2014/main" id="{B2E3F309-0E44-499C-9C14-73E7BCBF2215}"/>
-              </a:ext>
-            </a:extLst>
-          </p:cNvPr>
-          <p:cNvSpPr>
-            <a:spLocks xmlns:a="http://schemas.openxmlformats.org/drawingml/2006/main" noGrp="1"/>
-          </p:cNvSpPr>
-          <p:nvPr/>
-        </p:nvSpPr>
-        <p:spPr>
-          <a:xfrm xmlns:a="http://schemas.openxmlformats.org/drawingml/2006/main">
-            <a:off x="457200" y="6362700"/>
-            <a:ext cx="11277600" cy="9525"/>
-          </a:xfrm>
-          <a:prstGeom xmlns:a="http://schemas.openxmlformats.org/drawingml/2006/main" prst="rect">
-            <a:avLst/>
-          </a:prstGeom>
-          <a:solidFill xmlns:a="http://schemas.openxmlformats.org/drawingml/2006/main">
-            <a:srgbClr val="262626"/>
-          </a:solidFill>
-          <a:ln xmlns:a="http://schemas.openxmlformats.org/drawingml/2006/main" w="0">
-            <a:solidFill>
-              <a:srgbClr val="262626"/>
-            </a:solidFill>
-            <a:prstDash val="solid"/>
-          </a:ln>
-        </p:spPr>
-      </p:sp>
-      <p:sp>
-        <p:nvSpPr>
-          <p:cNvPr id="8" name="page-3">
-            <a:extLst xmlns:a="http://schemas.openxmlformats.org/drawingml/2006/main">
-              <a:ext uri="{FF2B5EF4-FFF2-40B4-BE49-F238E27FC236}">
-                <a16:creationId xmlns:a16="http://schemas.microsoft.com/office/drawing/2014/main" id="{8BA90A62-2127-45E6-BADA-F202A7D68752}"/>
-              </a:ext>
-            </a:extLst>
-          </p:cNvPr>
-          <p:cNvSpPr>
-            <a:spLocks xmlns:a="http://schemas.openxmlformats.org/drawingml/2006/main" noGrp="1"/>
-          </p:cNvSpPr>
-          <p:nvPr/>
-        </p:nvSpPr>
-        <p:spPr>
-          <a:xfrm xmlns:a="http://schemas.openxmlformats.org/drawingml/2006/main">
-            <a:off x="11220450" y="6496050"/>
-            <a:ext cx="514350" cy="209550"/>
+          <p:cNvPr id="9" name="input-kicker">
+            <a:extLst xmlns:a="http://schemas.openxmlformats.org/drawingml/2006/main">
+              <a:ext uri="{FF2B5EF4-FFF2-40B4-BE49-F238E27FC236}">
+                <a16:creationId xmlns:a16="http://schemas.microsoft.com/office/drawing/2014/main" id="{EB2C92A2-A34D-4E1F-B93B-E977A8AEDE9D}"/>
+              </a:ext>
+            </a:extLst>
+          </p:cNvPr>
+          <p:cNvSpPr>
+            <a:spLocks xmlns:a="http://schemas.openxmlformats.org/drawingml/2006/main" noGrp="1"/>
+          </p:cNvSpPr>
+          <p:nvPr/>
+        </p:nvSpPr>
+        <p:spPr>
+          <a:xfrm xmlns:a="http://schemas.openxmlformats.org/drawingml/2006/main">
+            <a:off x="762000" y="971550"/>
+            <a:ext cx="4572000" cy="247650"/>
           </a:xfrm>
           <a:prstGeom xmlns:a="http://schemas.openxmlformats.org/drawingml/2006/main" prst="rect">
             <a:avLst/>
@@ -3159,11 +3041,11 @@
           </a:bodyPr>
           <a:lstStyle xmlns:a="http://schemas.openxmlformats.org/drawingml/2006/main"/>
           <a:p xmlns:a="http://schemas.openxmlformats.org/drawingml/2006/main">
-            <a:pPr algn="r">
+            <a:pPr algn="l">
               <a:buNone/>
-              <a:defRPr sz="975" b="0">
-                <a:solidFill>
-                  <a:srgbClr val="666666"/>
+              <a:defRPr sz="1125" b="1">
+                <a:solidFill>
+                  <a:srgbClr val="65D49A"/>
                 </a:solidFill>
                 <a:latin typeface="Arial"/>
                 <a:ea typeface="Arial"/>
@@ -3171,37 +3053,37 @@
               </a:defRPr>
             </a:pPr>
             <a:r>
-              <a:rPr sz="975" b="0">
-                <a:solidFill>
-                  <a:srgbClr val="666666"/>
+              <a:rPr sz="1125" b="1">
+                <a:solidFill>
+                  <a:srgbClr val="65D49A"/>
                 </a:solidFill>
                 <a:latin typeface="Arial"/>
                 <a:ea typeface="Arial"/>
                 <a:cs typeface="Arial"/>
               </a:rPr>
-              <a:t>03</a:t>
+              <a:t>PRODUCT CONCEPT / SYNTHETIC SCENARIO</a:t>
             </a:r>
           </a:p>
         </p:txBody>
       </p:sp>
       <p:sp>
         <p:nvSpPr>
-          <p:cNvPr id="9" name="input-kicker">
-            <a:extLst xmlns:a="http://schemas.openxmlformats.org/drawingml/2006/main">
-              <a:ext uri="{FF2B5EF4-FFF2-40B4-BE49-F238E27FC236}">
-                <a16:creationId xmlns:a16="http://schemas.microsoft.com/office/drawing/2014/main" id="{EB2C92A2-A34D-4E1F-B93B-E977A8AEDE9D}"/>
-              </a:ext>
-            </a:extLst>
-          </p:cNvPr>
-          <p:cNvSpPr>
-            <a:spLocks xmlns:a="http://schemas.openxmlformats.org/drawingml/2006/main" noGrp="1"/>
-          </p:cNvSpPr>
-          <p:nvPr/>
-        </p:nvSpPr>
-        <p:spPr>
-          <a:xfrm xmlns:a="http://schemas.openxmlformats.org/drawingml/2006/main">
-            <a:off x="762000" y="971550"/>
-            <a:ext cx="4572000" cy="247650"/>
+          <p:cNvPr id="10" name="input-title">
+            <a:extLst xmlns:a="http://schemas.openxmlformats.org/drawingml/2006/main">
+              <a:ext uri="{FF2B5EF4-FFF2-40B4-BE49-F238E27FC236}">
+                <a16:creationId xmlns:a16="http://schemas.microsoft.com/office/drawing/2014/main" id="{EE68967E-8C61-4726-AF6D-600F7F3F8465}"/>
+              </a:ext>
+            </a:extLst>
+          </p:cNvPr>
+          <p:cNvSpPr>
+            <a:spLocks xmlns:a="http://schemas.openxmlformats.org/drawingml/2006/main" noGrp="1"/>
+          </p:cNvSpPr>
+          <p:nvPr/>
+        </p:nvSpPr>
+        <p:spPr>
+          <a:xfrm xmlns:a="http://schemas.openxmlformats.org/drawingml/2006/main">
+            <a:off x="762000" y="1466850"/>
+            <a:ext cx="4572000" cy="1219200"/>
           </a:xfrm>
           <a:prstGeom xmlns:a="http://schemas.openxmlformats.org/drawingml/2006/main" prst="rect">
             <a:avLst/>
@@ -3220,9 +3102,9 @@
           <a:p xmlns:a="http://schemas.openxmlformats.org/drawingml/2006/main">
             <a:pPr algn="l">
               <a:buNone/>
-              <a:defRPr sz="1125" b="1">
-                <a:solidFill>
-                  <a:srgbClr val="65D49A"/>
+              <a:defRPr sz="3750" b="1">
+                <a:solidFill>
+                  <a:srgbClr val="FFFFFF"/>
                 </a:solidFill>
                 <a:latin typeface="Arial"/>
                 <a:ea typeface="Arial"/>
@@ -3230,37 +3112,61 @@
               </a:defRPr>
             </a:pPr>
             <a:r>
-              <a:rPr sz="1125" b="1">
-                <a:solidFill>
-                  <a:srgbClr val="65D49A"/>
+              <a:rPr sz="3750" b="1">
+                <a:solidFill>
+                  <a:srgbClr val="FFFFFF"/>
                 </a:solidFill>
                 <a:latin typeface="Arial"/>
                 <a:ea typeface="Arial"/>
                 <a:cs typeface="Arial"/>
               </a:rPr>
-              <a:t>PRODUCT CONCEPT / SYNTHETIC SCENARIO</a:t>
+              <a:t>She controls</a:t>
+            </a:r>
+          </a:p>
+          <a:p xmlns:a="http://schemas.openxmlformats.org/drawingml/2006/main">
+            <a:pPr algn="l">
+              <a:buNone/>
+              <a:defRPr sz="3750" b="1">
+                <a:solidFill>
+                  <a:srgbClr val="FFFFFF"/>
+                </a:solidFill>
+                <a:latin typeface="Arial"/>
+                <a:ea typeface="Arial"/>
+                <a:cs typeface="Arial"/>
+              </a:defRPr>
+            </a:pPr>
+            <a:r>
+              <a:rPr sz="3750" b="1">
+                <a:solidFill>
+                  <a:srgbClr val="FFFFFF"/>
+                </a:solidFill>
+                <a:latin typeface="Arial"/>
+                <a:ea typeface="Arial"/>
+                <a:cs typeface="Arial"/>
+              </a:rPr>
+              <a:t>the handoff.</a:t>
             </a:r>
           </a:p>
         </p:txBody>
       </p:sp>
       <p:sp>
         <p:nvSpPr>
-          <p:cNvPr id="10" name="input-title">
-            <a:extLst xmlns:a="http://schemas.openxmlformats.org/drawingml/2006/main">
-              <a:ext uri="{FF2B5EF4-FFF2-40B4-BE49-F238E27FC236}">
-                <a16:creationId xmlns:a16="http://schemas.microsoft.com/office/drawing/2014/main" id="{EE68967E-8C61-4726-AF6D-600F7F3F8465}"/>
-              </a:ext>
-            </a:extLst>
-          </p:cNvPr>
-          <p:cNvSpPr>
-            <a:spLocks xmlns:a="http://schemas.openxmlformats.org/drawingml/2006/main" noGrp="1"/>
-          </p:cNvSpPr>
-          <p:nvPr/>
-        </p:nvSpPr>
-        <p:spPr>
-          <a:xfrm xmlns:a="http://schemas.openxmlformats.org/drawingml/2006/main">
-            <a:off x="762000" y="1466850"/>
-            <a:ext cx="4572000" cy="1219200"/>
+          <p:cNvPr id="11" name="input-copy">
+            <a:extLst xmlns:a="http://schemas.openxmlformats.org/drawingml/2006/main">
+              <a:ext uri="{FF2B5EF4-FFF2-40B4-BE49-F238E27FC236}">
+                <a16:creationId xmlns:a16="http://schemas.microsoft.com/office/drawing/2014/main" id="{038B2A36-BFC3-499F-A689-FDFB500A904F}"/>
+              </a:ext>
+            </a:extLst>
+          </p:cNvPr>
+          <p:cNvSpPr>
+            <a:spLocks xmlns:a="http://schemas.openxmlformats.org/drawingml/2006/main" noGrp="1"/>
+          </p:cNvSpPr>
+          <p:nvPr/>
+        </p:nvSpPr>
+        <p:spPr>
+          <a:xfrm xmlns:a="http://schemas.openxmlformats.org/drawingml/2006/main">
+            <a:off x="762000" y="3162300"/>
+            <a:ext cx="4286250" cy="781050"/>
           </a:xfrm>
           <a:prstGeom xmlns:a="http://schemas.openxmlformats.org/drawingml/2006/main" prst="rect">
             <a:avLst/>
@@ -3279,9 +3185,9 @@
           <a:p xmlns:a="http://schemas.openxmlformats.org/drawingml/2006/main">
             <a:pPr algn="l">
               <a:buNone/>
-              <a:defRPr sz="3750" b="1">
-                <a:solidFill>
-                  <a:srgbClr val="FFFFFF"/>
+              <a:defRPr sz="1950" b="0">
+                <a:solidFill>
+                  <a:srgbClr val="EDEDED"/>
                 </a:solidFill>
                 <a:latin typeface="Arial"/>
                 <a:ea typeface="Arial"/>
@@ -3289,23 +3195,23 @@
               </a:defRPr>
             </a:pPr>
             <a:r>
-              <a:rPr sz="3750" b="1">
-                <a:solidFill>
-                  <a:srgbClr val="FFFFFF"/>
+              <a:rPr sz="1950" b="0">
+                <a:solidFill>
+                  <a:srgbClr val="EDEDED"/>
                 </a:solidFill>
                 <a:latin typeface="Arial"/>
                 <a:ea typeface="Arial"/>
                 <a:cs typeface="Arial"/>
               </a:rPr>
-              <a:t>She controls</a:t>
+              <a:t>Review the manifest.</a:t>
             </a:r>
           </a:p>
           <a:p xmlns:a="http://schemas.openxmlformats.org/drawingml/2006/main">
             <a:pPr algn="l">
               <a:buNone/>
-              <a:defRPr sz="3750" b="1">
-                <a:solidFill>
-                  <a:srgbClr val="FFFFFF"/>
+              <a:defRPr sz="1950" b="0">
+                <a:solidFill>
+                  <a:srgbClr val="EDEDED"/>
                 </a:solidFill>
                 <a:latin typeface="Arial"/>
                 <a:ea typeface="Arial"/>
@@ -3313,37 +3219,70 @@
               </a:defRPr>
             </a:pPr>
             <a:r>
-              <a:rPr sz="3750" b="1">
-                <a:solidFill>
-                  <a:srgbClr val="FFFFFF"/>
+              <a:rPr sz="1950" b="0">
+                <a:solidFill>
+                  <a:srgbClr val="EDEDED"/>
                 </a:solidFill>
                 <a:latin typeface="Arial"/>
                 <a:ea typeface="Arial"/>
                 <a:cs typeface="Arial"/>
               </a:rPr>
-              <a:t>the handoff.</a:t>
+              <a:t>Edit, delete, or withhold.</a:t>
             </a:r>
           </a:p>
         </p:txBody>
       </p:sp>
       <p:sp>
         <p:nvSpPr>
-          <p:cNvPr id="11" name="input-copy">
-            <a:extLst xmlns:a="http://schemas.openxmlformats.org/drawingml/2006/main">
-              <a:ext uri="{FF2B5EF4-FFF2-40B4-BE49-F238E27FC236}">
-                <a16:creationId xmlns:a16="http://schemas.microsoft.com/office/drawing/2014/main" id="{038B2A36-BFC3-499F-A689-FDFB500A904F}"/>
-              </a:ext>
-            </a:extLst>
-          </p:cNvPr>
-          <p:cNvSpPr>
-            <a:spLocks xmlns:a="http://schemas.openxmlformats.org/drawingml/2006/main" noGrp="1"/>
-          </p:cNvSpPr>
-          <p:nvPr/>
-        </p:nvSpPr>
-        <p:spPr>
-          <a:xfrm xmlns:a="http://schemas.openxmlformats.org/drawingml/2006/main">
-            <a:off x="762000" y="3162300"/>
-            <a:ext cx="4286250" cy="781050"/>
+          <p:cNvPr id="12" name="input-accent">
+            <a:extLst xmlns:a="http://schemas.openxmlformats.org/drawingml/2006/main">
+              <a:ext uri="{FF2B5EF4-FFF2-40B4-BE49-F238E27FC236}">
+                <a16:creationId xmlns:a16="http://schemas.microsoft.com/office/drawing/2014/main" id="{03C018AA-EE3A-4CB6-BE58-3272F5AB67AF}"/>
+              </a:ext>
+            </a:extLst>
+          </p:cNvPr>
+          <p:cNvSpPr>
+            <a:spLocks xmlns:a="http://schemas.openxmlformats.org/drawingml/2006/main" noGrp="1"/>
+          </p:cNvSpPr>
+          <p:nvPr/>
+        </p:nvSpPr>
+        <p:spPr>
+          <a:xfrm xmlns:a="http://schemas.openxmlformats.org/drawingml/2006/main">
+            <a:off x="762000" y="4629150"/>
+            <a:ext cx="609600" cy="28575"/>
+          </a:xfrm>
+          <a:prstGeom xmlns:a="http://schemas.openxmlformats.org/drawingml/2006/main" prst="rect">
+            <a:avLst/>
+          </a:prstGeom>
+          <a:solidFill xmlns:a="http://schemas.openxmlformats.org/drawingml/2006/main">
+            <a:srgbClr val="65D49A"/>
+          </a:solidFill>
+          <a:ln xmlns:a="http://schemas.openxmlformats.org/drawingml/2006/main" w="0">
+            <a:solidFill>
+              <a:srgbClr val="65D49A"/>
+            </a:solidFill>
+            <a:prstDash val="solid"/>
+          </a:ln>
+        </p:spPr>
+      </p:sp>
+      <p:sp>
+        <p:nvSpPr>
+          <p:cNvPr id="13" name="input-boundary">
+            <a:extLst xmlns:a="http://schemas.openxmlformats.org/drawingml/2006/main">
+              <a:ext uri="{FF2B5EF4-FFF2-40B4-BE49-F238E27FC236}">
+                <a16:creationId xmlns:a16="http://schemas.microsoft.com/office/drawing/2014/main" id="{B27A89B7-5FD1-4A45-ADD9-E78B3C1D8782}"/>
+              </a:ext>
+            </a:extLst>
+          </p:cNvPr>
+          <p:cNvSpPr>
+            <a:spLocks xmlns:a="http://schemas.openxmlformats.org/drawingml/2006/main" noGrp="1"/>
+          </p:cNvSpPr>
+          <p:nvPr/>
+        </p:nvSpPr>
+        <p:spPr>
+          <a:xfrm xmlns:a="http://schemas.openxmlformats.org/drawingml/2006/main">
+            <a:off x="762000" y="4895850"/>
+            <a:ext cx="4286250" cy="723900"/>
           </a:xfrm>
           <a:prstGeom xmlns:a="http://schemas.openxmlformats.org/drawingml/2006/main" prst="rect">
             <a:avLst/>
@@ -3362,122 +3301,6 @@
           <a:p xmlns:a="http://schemas.openxmlformats.org/drawingml/2006/main">
             <a:pPr algn="l">
               <a:buNone/>
-              <a:defRPr sz="1950" b="0">
-                <a:solidFill>
-                  <a:srgbClr val="EDEDED"/>
-                </a:solidFill>
-                <a:latin typeface="Arial"/>
-                <a:ea typeface="Arial"/>
-                <a:cs typeface="Arial"/>
-              </a:defRPr>
-            </a:pPr>
-            <a:r>
-              <a:rPr sz="1950" b="0">
-                <a:solidFill>
-                  <a:srgbClr val="EDEDED"/>
-                </a:solidFill>
-                <a:latin typeface="Arial"/>
-                <a:ea typeface="Arial"/>
-                <a:cs typeface="Arial"/>
-              </a:rPr>
-              <a:t>Review the manifest.</a:t>
-            </a:r>
-          </a:p>
-          <a:p xmlns:a="http://schemas.openxmlformats.org/drawingml/2006/main">
-            <a:pPr algn="l">
-              <a:buNone/>
-              <a:defRPr sz="1950" b="0">
-                <a:solidFill>
-                  <a:srgbClr val="EDEDED"/>
-                </a:solidFill>
-                <a:latin typeface="Arial"/>
-                <a:ea typeface="Arial"/>
-                <a:cs typeface="Arial"/>
-              </a:defRPr>
-            </a:pPr>
-            <a:r>
-              <a:rPr sz="1950" b="0">
-                <a:solidFill>
-                  <a:srgbClr val="EDEDED"/>
-                </a:solidFill>
-                <a:latin typeface="Arial"/>
-                <a:ea typeface="Arial"/>
-                <a:cs typeface="Arial"/>
-              </a:rPr>
-              <a:t>Edit, delete, or withhold.</a:t>
-            </a:r>
-          </a:p>
-        </p:txBody>
-      </p:sp>
-      <p:sp>
-        <p:nvSpPr>
-          <p:cNvPr id="12" name="input-accent">
-            <a:extLst xmlns:a="http://schemas.openxmlformats.org/drawingml/2006/main">
-              <a:ext uri="{FF2B5EF4-FFF2-40B4-BE49-F238E27FC236}">
-                <a16:creationId xmlns:a16="http://schemas.microsoft.com/office/drawing/2014/main" id="{03C018AA-EE3A-4CB6-BE58-3272F5AB67AF}"/>
-              </a:ext>
-            </a:extLst>
-          </p:cNvPr>
-          <p:cNvSpPr>
-            <a:spLocks xmlns:a="http://schemas.openxmlformats.org/drawingml/2006/main" noGrp="1"/>
-          </p:cNvSpPr>
-          <p:nvPr/>
-        </p:nvSpPr>
-        <p:spPr>
-          <a:xfrm xmlns:a="http://schemas.openxmlformats.org/drawingml/2006/main">
-            <a:off x="762000" y="4629150"/>
-            <a:ext cx="609600" cy="28575"/>
-          </a:xfrm>
-          <a:prstGeom xmlns:a="http://schemas.openxmlformats.org/drawingml/2006/main" prst="rect">
-            <a:avLst/>
-          </a:prstGeom>
-          <a:solidFill xmlns:a="http://schemas.openxmlformats.org/drawingml/2006/main">
-            <a:srgbClr val="65D49A"/>
-          </a:solidFill>
-          <a:ln xmlns:a="http://schemas.openxmlformats.org/drawingml/2006/main" w="0">
-            <a:solidFill>
-              <a:srgbClr val="65D49A"/>
-            </a:solidFill>
-            <a:prstDash val="solid"/>
-          </a:ln>
-        </p:spPr>
-      </p:sp>
-      <p:sp>
-        <p:nvSpPr>
-          <p:cNvPr id="13" name="input-boundary">
-            <a:extLst xmlns:a="http://schemas.openxmlformats.org/drawingml/2006/main">
-              <a:ext uri="{FF2B5EF4-FFF2-40B4-BE49-F238E27FC236}">
-                <a16:creationId xmlns:a16="http://schemas.microsoft.com/office/drawing/2014/main" id="{B27A89B7-5FD1-4A45-ADD9-E78B3C1D8782}"/>
-              </a:ext>
-            </a:extLst>
-          </p:cNvPr>
-          <p:cNvSpPr>
-            <a:spLocks xmlns:a="http://schemas.openxmlformats.org/drawingml/2006/main" noGrp="1"/>
-          </p:cNvSpPr>
-          <p:nvPr/>
-        </p:nvSpPr>
-        <p:spPr>
-          <a:xfrm xmlns:a="http://schemas.openxmlformats.org/drawingml/2006/main">
-            <a:off x="762000" y="4895850"/>
-            <a:ext cx="4286250" cy="723900"/>
-          </a:xfrm>
-          <a:prstGeom xmlns:a="http://schemas.openxmlformats.org/drawingml/2006/main" prst="rect">
-            <a:avLst/>
-          </a:prstGeom>
-          <a:noFill xmlns:a="http://schemas.openxmlformats.org/drawingml/2006/main"/>
-          <a:ln xmlns:a="http://schemas.openxmlformats.org/drawingml/2006/main" w="0">
-            <a:noFill/>
-            <a:prstDash val="solid"/>
-          </a:ln>
-        </p:spPr>
-        <p:txBody>
-          <a:bodyPr xmlns:a="http://schemas.openxmlformats.org/drawingml/2006/main" wrap="square" lIns="0" tIns="0" rIns="0" bIns="0" anchor="t">
-            <a:noAutofit/>
-          </a:bodyPr>
-          <a:lstStyle xmlns:a="http://schemas.openxmlformats.org/drawingml/2006/main"/>
-          <a:p xmlns:a="http://schemas.openxmlformats.org/drawingml/2006/main">
-            <a:pPr algn="l">
-              <a:buNone/>
               <a:defRPr sz="1500" b="0">
                 <a:solidFill>
                   <a:srgbClr val="A1A1A1"/>
@@ -3560,14 +3383,14 @@
       </p:sp>
       <p:pic>
         <p:nvPicPr>
-          <p:cNvPr id="32" name=""/>
+          <p:cNvPr id="31" name=""/>
           <p:cNvPicPr>
             <a:picLocks xmlns:a="http://schemas.openxmlformats.org/drawingml/2006/main" noChangeAspect="1"/>
           </p:cNvPicPr>
           <p:nvPr/>
         </p:nvPicPr>
         <p:blipFill>
-          <a:blip xmlns:r="http://schemas.openxmlformats.org/officeDocument/2006/relationships" xmlns:a="http://schemas.openxmlformats.org/drawingml/2006/main" r:embed="R9615484ec4d8434d"/>
+          <a:blip xmlns:r="http://schemas.openxmlformats.org/officeDocument/2006/relationships" xmlns:a="http://schemas.openxmlformats.org/drawingml/2006/main" r:embed="Rf8bc050f505a428f"/>
           <a:srcRect xmlns:a="http://schemas.openxmlformats.org/drawingml/2006/main" l="112" t="0" r="112" b="0"/>
           <a:stretch xmlns:a="http://schemas.openxmlformats.org/drawingml/2006/main">
             <a:fillRect l="0" t="0" r="0" b="0"/>
@@ -3673,22 +3496,187 @@
       </p:sp>
       <p:sp>
         <p:nvSpPr>
-          <p:cNvPr id="2" name="round-4">
-            <a:extLst xmlns:a="http://schemas.openxmlformats.org/drawingml/2006/main">
-              <a:ext uri="{FF2B5EF4-FFF2-40B4-BE49-F238E27FC236}">
-                <a16:creationId xmlns:a16="http://schemas.microsoft.com/office/drawing/2014/main" id="{ACF6D306-EA22-465B-9E7C-9CBFD5BB6201}"/>
-              </a:ext>
-            </a:extLst>
-          </p:cNvPr>
-          <p:cNvSpPr>
-            <a:spLocks xmlns:a="http://schemas.openxmlformats.org/drawingml/2006/main" noGrp="1"/>
-          </p:cNvSpPr>
-          <p:nvPr/>
-        </p:nvSpPr>
-        <p:spPr>
-          <a:xfrm xmlns:a="http://schemas.openxmlformats.org/drawingml/2006/main">
-            <a:off x="9334500" y="247650"/>
-            <a:ext cx="2400300" cy="247650"/>
+          <p:cNvPr id="3" name="top-rule-4">
+            <a:extLst xmlns:a="http://schemas.openxmlformats.org/drawingml/2006/main">
+              <a:ext uri="{FF2B5EF4-FFF2-40B4-BE49-F238E27FC236}">
+                <a16:creationId xmlns:a16="http://schemas.microsoft.com/office/drawing/2014/main" id="{5B7AE2B1-5F8B-4C2A-ABF2-4C294561558B}"/>
+              </a:ext>
+            </a:extLst>
+          </p:cNvPr>
+          <p:cNvSpPr>
+            <a:spLocks xmlns:a="http://schemas.openxmlformats.org/drawingml/2006/main" noGrp="1"/>
+          </p:cNvSpPr>
+          <p:nvPr/>
+        </p:nvSpPr>
+        <p:spPr>
+          <a:xfrm xmlns:a="http://schemas.openxmlformats.org/drawingml/2006/main">
+            <a:off x="457200" y="609600"/>
+            <a:ext cx="11277600" cy="9525"/>
+          </a:xfrm>
+          <a:prstGeom xmlns:a="http://schemas.openxmlformats.org/drawingml/2006/main" prst="rect">
+            <a:avLst/>
+          </a:prstGeom>
+          <a:solidFill xmlns:a="http://schemas.openxmlformats.org/drawingml/2006/main">
+            <a:srgbClr val="262626"/>
+          </a:solidFill>
+          <a:ln xmlns:a="http://schemas.openxmlformats.org/drawingml/2006/main" w="0">
+            <a:solidFill>
+              <a:srgbClr val="262626"/>
+            </a:solidFill>
+            <a:prstDash val="solid"/>
+          </a:ln>
+        </p:spPr>
+      </p:sp>
+      <p:sp>
+        <p:nvSpPr>
+          <p:cNvPr id="4" name="left-grid-4">
+            <a:extLst xmlns:a="http://schemas.openxmlformats.org/drawingml/2006/main">
+              <a:ext uri="{FF2B5EF4-FFF2-40B4-BE49-F238E27FC236}">
+                <a16:creationId xmlns:a16="http://schemas.microsoft.com/office/drawing/2014/main" id="{17A3BBDC-0D56-47F1-BA81-8CE51615114D}"/>
+              </a:ext>
+            </a:extLst>
+          </p:cNvPr>
+          <p:cNvSpPr>
+            <a:spLocks xmlns:a="http://schemas.openxmlformats.org/drawingml/2006/main" noGrp="1"/>
+          </p:cNvSpPr>
+          <p:nvPr/>
+        </p:nvSpPr>
+        <p:spPr>
+          <a:xfrm xmlns:a="http://schemas.openxmlformats.org/drawingml/2006/main">
+            <a:off x="457200" y="609600"/>
+            <a:ext cx="9525" cy="5753100"/>
+          </a:xfrm>
+          <a:prstGeom xmlns:a="http://schemas.openxmlformats.org/drawingml/2006/main" prst="rect">
+            <a:avLst/>
+          </a:prstGeom>
+          <a:solidFill xmlns:a="http://schemas.openxmlformats.org/drawingml/2006/main">
+            <a:srgbClr val="262626"/>
+          </a:solidFill>
+          <a:ln xmlns:a="http://schemas.openxmlformats.org/drawingml/2006/main" w="0">
+            <a:solidFill>
+              <a:srgbClr val="262626"/>
+            </a:solidFill>
+            <a:prstDash val="solid"/>
+          </a:ln>
+        </p:spPr>
+      </p:sp>
+      <p:sp>
+        <p:nvSpPr>
+          <p:cNvPr id="5" name="center-grid-4">
+            <a:extLst xmlns:a="http://schemas.openxmlformats.org/drawingml/2006/main">
+              <a:ext uri="{FF2B5EF4-FFF2-40B4-BE49-F238E27FC236}">
+                <a16:creationId xmlns:a16="http://schemas.microsoft.com/office/drawing/2014/main" id="{91BB188E-E349-40AF-BD60-8C1E6566CC6F}"/>
+              </a:ext>
+            </a:extLst>
+          </p:cNvPr>
+          <p:cNvSpPr>
+            <a:spLocks xmlns:a="http://schemas.openxmlformats.org/drawingml/2006/main" noGrp="1"/>
+          </p:cNvSpPr>
+          <p:nvPr/>
+        </p:nvSpPr>
+        <p:spPr>
+          <a:xfrm xmlns:a="http://schemas.openxmlformats.org/drawingml/2006/main">
+            <a:off x="6096000" y="609600"/>
+            <a:ext cx="9525" cy="5753100"/>
+          </a:xfrm>
+          <a:prstGeom xmlns:a="http://schemas.openxmlformats.org/drawingml/2006/main" prst="rect">
+            <a:avLst/>
+          </a:prstGeom>
+          <a:solidFill xmlns:a="http://schemas.openxmlformats.org/drawingml/2006/main">
+            <a:srgbClr val="262626"/>
+          </a:solidFill>
+          <a:ln xmlns:a="http://schemas.openxmlformats.org/drawingml/2006/main" w="0">
+            <a:solidFill>
+              <a:srgbClr val="262626"/>
+            </a:solidFill>
+            <a:prstDash val="solid"/>
+          </a:ln>
+        </p:spPr>
+      </p:sp>
+      <p:sp>
+        <p:nvSpPr>
+          <p:cNvPr id="6" name="right-grid-4">
+            <a:extLst xmlns:a="http://schemas.openxmlformats.org/drawingml/2006/main">
+              <a:ext uri="{FF2B5EF4-FFF2-40B4-BE49-F238E27FC236}">
+                <a16:creationId xmlns:a16="http://schemas.microsoft.com/office/drawing/2014/main" id="{BD328320-0D67-4617-80F3-1DA42E41F8A9}"/>
+              </a:ext>
+            </a:extLst>
+          </p:cNvPr>
+          <p:cNvSpPr>
+            <a:spLocks xmlns:a="http://schemas.openxmlformats.org/drawingml/2006/main" noGrp="1"/>
+          </p:cNvSpPr>
+          <p:nvPr/>
+        </p:nvSpPr>
+        <p:spPr>
+          <a:xfrm xmlns:a="http://schemas.openxmlformats.org/drawingml/2006/main">
+            <a:off x="11725275" y="609600"/>
+            <a:ext cx="9525" cy="5753100"/>
+          </a:xfrm>
+          <a:prstGeom xmlns:a="http://schemas.openxmlformats.org/drawingml/2006/main" prst="rect">
+            <a:avLst/>
+          </a:prstGeom>
+          <a:solidFill xmlns:a="http://schemas.openxmlformats.org/drawingml/2006/main">
+            <a:srgbClr val="262626"/>
+          </a:solidFill>
+          <a:ln xmlns:a="http://schemas.openxmlformats.org/drawingml/2006/main" w="0">
+            <a:solidFill>
+              <a:srgbClr val="262626"/>
+            </a:solidFill>
+            <a:prstDash val="solid"/>
+          </a:ln>
+        </p:spPr>
+      </p:sp>
+      <p:sp>
+        <p:nvSpPr>
+          <p:cNvPr id="7" name="bottom-rule-4">
+            <a:extLst xmlns:a="http://schemas.openxmlformats.org/drawingml/2006/main">
+              <a:ext uri="{FF2B5EF4-FFF2-40B4-BE49-F238E27FC236}">
+                <a16:creationId xmlns:a16="http://schemas.microsoft.com/office/drawing/2014/main" id="{0BFB3843-7388-473E-A2AE-6AB1892167AC}"/>
+              </a:ext>
+            </a:extLst>
+          </p:cNvPr>
+          <p:cNvSpPr>
+            <a:spLocks xmlns:a="http://schemas.openxmlformats.org/drawingml/2006/main" noGrp="1"/>
+          </p:cNvSpPr>
+          <p:nvPr/>
+        </p:nvSpPr>
+        <p:spPr>
+          <a:xfrm xmlns:a="http://schemas.openxmlformats.org/drawingml/2006/main">
+            <a:off x="457200" y="6362700"/>
+            <a:ext cx="11277600" cy="9525"/>
+          </a:xfrm>
+          <a:prstGeom xmlns:a="http://schemas.openxmlformats.org/drawingml/2006/main" prst="rect">
+            <a:avLst/>
+          </a:prstGeom>
+          <a:solidFill xmlns:a="http://schemas.openxmlformats.org/drawingml/2006/main">
+            <a:srgbClr val="262626"/>
+          </a:solidFill>
+          <a:ln xmlns:a="http://schemas.openxmlformats.org/drawingml/2006/main" w="0">
+            <a:solidFill>
+              <a:srgbClr val="262626"/>
+            </a:solidFill>
+            <a:prstDash val="solid"/>
+          </a:ln>
+        </p:spPr>
+      </p:sp>
+      <p:sp>
+        <p:nvSpPr>
+          <p:cNvPr id="8" name="page-4">
+            <a:extLst xmlns:a="http://schemas.openxmlformats.org/drawingml/2006/main">
+              <a:ext uri="{FF2B5EF4-FFF2-40B4-BE49-F238E27FC236}">
+                <a16:creationId xmlns:a16="http://schemas.microsoft.com/office/drawing/2014/main" id="{47080BD6-AE6A-46D0-81A3-3C63679CF237}"/>
+              </a:ext>
+            </a:extLst>
+          </p:cNvPr>
+          <p:cNvSpPr>
+            <a:spLocks xmlns:a="http://schemas.openxmlformats.org/drawingml/2006/main" noGrp="1"/>
+          </p:cNvSpPr>
+          <p:nvPr/>
+        </p:nvSpPr>
+        <p:spPr>
+          <a:xfrm xmlns:a="http://schemas.openxmlformats.org/drawingml/2006/main">
+            <a:off x="11220450" y="6496050"/>
+            <a:ext cx="514350" cy="209550"/>
           </a:xfrm>
           <a:prstGeom xmlns:a="http://schemas.openxmlformats.org/drawingml/2006/main" prst="rect">
             <a:avLst/>
@@ -3707,9 +3695,9 @@
           <a:p xmlns:a="http://schemas.openxmlformats.org/drawingml/2006/main">
             <a:pPr algn="r">
               <a:buNone/>
-              <a:defRPr sz="1125" b="0">
-                <a:solidFill>
-                  <a:srgbClr val="A1A1A1"/>
+              <a:defRPr sz="975" b="0">
+                <a:solidFill>
+                  <a:srgbClr val="666666"/>
                 </a:solidFill>
                 <a:latin typeface="Arial"/>
                 <a:ea typeface="Arial"/>
@@ -3717,202 +3705,37 @@
               </a:defRPr>
             </a:pPr>
             <a:r>
-              <a:rPr sz="1125" b="0">
-                <a:solidFill>
-                  <a:srgbClr val="A1A1A1"/>
+              <a:rPr sz="975" b="0">
+                <a:solidFill>
+                  <a:srgbClr val="666666"/>
                 </a:solidFill>
                 <a:latin typeface="Arial"/>
                 <a:ea typeface="Arial"/>
                 <a:cs typeface="Arial"/>
               </a:rPr>
-              <a:t>ACU / ROUND 2</a:t>
+              <a:t>04</a:t>
             </a:r>
           </a:p>
         </p:txBody>
       </p:sp>
       <p:sp>
         <p:nvSpPr>
-          <p:cNvPr id="3" name="top-rule-4">
-            <a:extLst xmlns:a="http://schemas.openxmlformats.org/drawingml/2006/main">
-              <a:ext uri="{FF2B5EF4-FFF2-40B4-BE49-F238E27FC236}">
-                <a16:creationId xmlns:a16="http://schemas.microsoft.com/office/drawing/2014/main" id="{5B7AE2B1-5F8B-4C2A-ABF2-4C294561558B}"/>
-              </a:ext>
-            </a:extLst>
-          </p:cNvPr>
-          <p:cNvSpPr>
-            <a:spLocks xmlns:a="http://schemas.openxmlformats.org/drawingml/2006/main" noGrp="1"/>
-          </p:cNvSpPr>
-          <p:nvPr/>
-        </p:nvSpPr>
-        <p:spPr>
-          <a:xfrm xmlns:a="http://schemas.openxmlformats.org/drawingml/2006/main">
-            <a:off x="457200" y="609600"/>
-            <a:ext cx="11277600" cy="9525"/>
-          </a:xfrm>
-          <a:prstGeom xmlns:a="http://schemas.openxmlformats.org/drawingml/2006/main" prst="rect">
-            <a:avLst/>
-          </a:prstGeom>
-          <a:solidFill xmlns:a="http://schemas.openxmlformats.org/drawingml/2006/main">
-            <a:srgbClr val="262626"/>
-          </a:solidFill>
-          <a:ln xmlns:a="http://schemas.openxmlformats.org/drawingml/2006/main" w="0">
-            <a:solidFill>
-              <a:srgbClr val="262626"/>
-            </a:solidFill>
-            <a:prstDash val="solid"/>
-          </a:ln>
-        </p:spPr>
-      </p:sp>
-      <p:sp>
-        <p:nvSpPr>
-          <p:cNvPr id="4" name="left-grid-4">
-            <a:extLst xmlns:a="http://schemas.openxmlformats.org/drawingml/2006/main">
-              <a:ext uri="{FF2B5EF4-FFF2-40B4-BE49-F238E27FC236}">
-                <a16:creationId xmlns:a16="http://schemas.microsoft.com/office/drawing/2014/main" id="{17A3BBDC-0D56-47F1-BA81-8CE51615114D}"/>
-              </a:ext>
-            </a:extLst>
-          </p:cNvPr>
-          <p:cNvSpPr>
-            <a:spLocks xmlns:a="http://schemas.openxmlformats.org/drawingml/2006/main" noGrp="1"/>
-          </p:cNvSpPr>
-          <p:nvPr/>
-        </p:nvSpPr>
-        <p:spPr>
-          <a:xfrm xmlns:a="http://schemas.openxmlformats.org/drawingml/2006/main">
-            <a:off x="457200" y="609600"/>
-            <a:ext cx="9525" cy="5753100"/>
-          </a:xfrm>
-          <a:prstGeom xmlns:a="http://schemas.openxmlformats.org/drawingml/2006/main" prst="rect">
-            <a:avLst/>
-          </a:prstGeom>
-          <a:solidFill xmlns:a="http://schemas.openxmlformats.org/drawingml/2006/main">
-            <a:srgbClr val="262626"/>
-          </a:solidFill>
-          <a:ln xmlns:a="http://schemas.openxmlformats.org/drawingml/2006/main" w="0">
-            <a:solidFill>
-              <a:srgbClr val="262626"/>
-            </a:solidFill>
-            <a:prstDash val="solid"/>
-          </a:ln>
-        </p:spPr>
-      </p:sp>
-      <p:sp>
-        <p:nvSpPr>
-          <p:cNvPr id="5" name="center-grid-4">
-            <a:extLst xmlns:a="http://schemas.openxmlformats.org/drawingml/2006/main">
-              <a:ext uri="{FF2B5EF4-FFF2-40B4-BE49-F238E27FC236}">
-                <a16:creationId xmlns:a16="http://schemas.microsoft.com/office/drawing/2014/main" id="{91BB188E-E349-40AF-BD60-8C1E6566CC6F}"/>
-              </a:ext>
-            </a:extLst>
-          </p:cNvPr>
-          <p:cNvSpPr>
-            <a:spLocks xmlns:a="http://schemas.openxmlformats.org/drawingml/2006/main" noGrp="1"/>
-          </p:cNvSpPr>
-          <p:nvPr/>
-        </p:nvSpPr>
-        <p:spPr>
-          <a:xfrm xmlns:a="http://schemas.openxmlformats.org/drawingml/2006/main">
-            <a:off x="6096000" y="609600"/>
-            <a:ext cx="9525" cy="5753100"/>
-          </a:xfrm>
-          <a:prstGeom xmlns:a="http://schemas.openxmlformats.org/drawingml/2006/main" prst="rect">
-            <a:avLst/>
-          </a:prstGeom>
-          <a:solidFill xmlns:a="http://schemas.openxmlformats.org/drawingml/2006/main">
-            <a:srgbClr val="262626"/>
-          </a:solidFill>
-          <a:ln xmlns:a="http://schemas.openxmlformats.org/drawingml/2006/main" w="0">
-            <a:solidFill>
-              <a:srgbClr val="262626"/>
-            </a:solidFill>
-            <a:prstDash val="solid"/>
-          </a:ln>
-        </p:spPr>
-      </p:sp>
-      <p:sp>
-        <p:nvSpPr>
-          <p:cNvPr id="6" name="right-grid-4">
-            <a:extLst xmlns:a="http://schemas.openxmlformats.org/drawingml/2006/main">
-              <a:ext uri="{FF2B5EF4-FFF2-40B4-BE49-F238E27FC236}">
-                <a16:creationId xmlns:a16="http://schemas.microsoft.com/office/drawing/2014/main" id="{BD328320-0D67-4617-80F3-1DA42E41F8A9}"/>
-              </a:ext>
-            </a:extLst>
-          </p:cNvPr>
-          <p:cNvSpPr>
-            <a:spLocks xmlns:a="http://schemas.openxmlformats.org/drawingml/2006/main" noGrp="1"/>
-          </p:cNvSpPr>
-          <p:nvPr/>
-        </p:nvSpPr>
-        <p:spPr>
-          <a:xfrm xmlns:a="http://schemas.openxmlformats.org/drawingml/2006/main">
-            <a:off x="11725275" y="609600"/>
-            <a:ext cx="9525" cy="5753100"/>
-          </a:xfrm>
-          <a:prstGeom xmlns:a="http://schemas.openxmlformats.org/drawingml/2006/main" prst="rect">
-            <a:avLst/>
-          </a:prstGeom>
-          <a:solidFill xmlns:a="http://schemas.openxmlformats.org/drawingml/2006/main">
-            <a:srgbClr val="262626"/>
-          </a:solidFill>
-          <a:ln xmlns:a="http://schemas.openxmlformats.org/drawingml/2006/main" w="0">
-            <a:solidFill>
-              <a:srgbClr val="262626"/>
-            </a:solidFill>
-            <a:prstDash val="solid"/>
-          </a:ln>
-        </p:spPr>
-      </p:sp>
-      <p:sp>
-        <p:nvSpPr>
-          <p:cNvPr id="7" name="bottom-rule-4">
-            <a:extLst xmlns:a="http://schemas.openxmlformats.org/drawingml/2006/main">
-              <a:ext uri="{FF2B5EF4-FFF2-40B4-BE49-F238E27FC236}">
-                <a16:creationId xmlns:a16="http://schemas.microsoft.com/office/drawing/2014/main" id="{0BFB3843-7388-473E-A2AE-6AB1892167AC}"/>
-              </a:ext>
-            </a:extLst>
-          </p:cNvPr>
-          <p:cNvSpPr>
-            <a:spLocks xmlns:a="http://schemas.openxmlformats.org/drawingml/2006/main" noGrp="1"/>
-          </p:cNvSpPr>
-          <p:nvPr/>
-        </p:nvSpPr>
-        <p:spPr>
-          <a:xfrm xmlns:a="http://schemas.openxmlformats.org/drawingml/2006/main">
-            <a:off x="457200" y="6362700"/>
-            <a:ext cx="11277600" cy="9525"/>
-          </a:xfrm>
-          <a:prstGeom xmlns:a="http://schemas.openxmlformats.org/drawingml/2006/main" prst="rect">
-            <a:avLst/>
-          </a:prstGeom>
-          <a:solidFill xmlns:a="http://schemas.openxmlformats.org/drawingml/2006/main">
-            <a:srgbClr val="262626"/>
-          </a:solidFill>
-          <a:ln xmlns:a="http://schemas.openxmlformats.org/drawingml/2006/main" w="0">
-            <a:solidFill>
-              <a:srgbClr val="262626"/>
-            </a:solidFill>
-            <a:prstDash val="solid"/>
-          </a:ln>
-        </p:spPr>
-      </p:sp>
-      <p:sp>
-        <p:nvSpPr>
-          <p:cNvPr id="8" name="page-4">
-            <a:extLst xmlns:a="http://schemas.openxmlformats.org/drawingml/2006/main">
-              <a:ext uri="{FF2B5EF4-FFF2-40B4-BE49-F238E27FC236}">
-                <a16:creationId xmlns:a16="http://schemas.microsoft.com/office/drawing/2014/main" id="{47080BD6-AE6A-46D0-81A3-3C63679CF237}"/>
-              </a:ext>
-            </a:extLst>
-          </p:cNvPr>
-          <p:cNvSpPr>
-            <a:spLocks xmlns:a="http://schemas.openxmlformats.org/drawingml/2006/main" noGrp="1"/>
-          </p:cNvSpPr>
-          <p:nvPr/>
-        </p:nvSpPr>
-        <p:spPr>
-          <a:xfrm xmlns:a="http://schemas.openxmlformats.org/drawingml/2006/main">
-            <a:off x="11220450" y="6496050"/>
-            <a:ext cx="514350" cy="209550"/>
+          <p:cNvPr id="9" name="output-kicker">
+            <a:extLst xmlns:a="http://schemas.openxmlformats.org/drawingml/2006/main">
+              <a:ext uri="{FF2B5EF4-FFF2-40B4-BE49-F238E27FC236}">
+                <a16:creationId xmlns:a16="http://schemas.microsoft.com/office/drawing/2014/main" id="{0A8259BC-A857-47A9-9189-41DAC05903FB}"/>
+              </a:ext>
+            </a:extLst>
+          </p:cNvPr>
+          <p:cNvSpPr>
+            <a:spLocks xmlns:a="http://schemas.openxmlformats.org/drawingml/2006/main" noGrp="1"/>
+          </p:cNvSpPr>
+          <p:nvPr/>
+        </p:nvSpPr>
+        <p:spPr>
+          <a:xfrm xmlns:a="http://schemas.openxmlformats.org/drawingml/2006/main">
+            <a:off x="762000" y="971550"/>
+            <a:ext cx="4000500" cy="247650"/>
           </a:xfrm>
           <a:prstGeom xmlns:a="http://schemas.openxmlformats.org/drawingml/2006/main" prst="rect">
             <a:avLst/>
@@ -3929,11 +3752,11 @@
           </a:bodyPr>
           <a:lstStyle xmlns:a="http://schemas.openxmlformats.org/drawingml/2006/main"/>
           <a:p xmlns:a="http://schemas.openxmlformats.org/drawingml/2006/main">
-            <a:pPr algn="r">
+            <a:pPr algn="l">
               <a:buNone/>
-              <a:defRPr sz="975" b="0">
-                <a:solidFill>
-                  <a:srgbClr val="666666"/>
+              <a:defRPr sz="1125" b="1">
+                <a:solidFill>
+                  <a:srgbClr val="65D49A"/>
                 </a:solidFill>
                 <a:latin typeface="Arial"/>
                 <a:ea typeface="Arial"/>
@@ -3941,37 +3764,37 @@
               </a:defRPr>
             </a:pPr>
             <a:r>
-              <a:rPr sz="975" b="0">
-                <a:solidFill>
-                  <a:srgbClr val="666666"/>
+              <a:rPr sz="1125" b="1">
+                <a:solidFill>
+                  <a:srgbClr val="65D49A"/>
                 </a:solidFill>
                 <a:latin typeface="Arial"/>
                 <a:ea typeface="Arial"/>
                 <a:cs typeface="Arial"/>
               </a:rPr>
-              <a:t>04</a:t>
+              <a:t>THE HUMAN HANDOFF</a:t>
             </a:r>
           </a:p>
         </p:txBody>
       </p:sp>
       <p:sp>
         <p:nvSpPr>
-          <p:cNvPr id="9" name="output-kicker">
-            <a:extLst xmlns:a="http://schemas.openxmlformats.org/drawingml/2006/main">
-              <a:ext uri="{FF2B5EF4-FFF2-40B4-BE49-F238E27FC236}">
-                <a16:creationId xmlns:a16="http://schemas.microsoft.com/office/drawing/2014/main" id="{0A8259BC-A857-47A9-9189-41DAC05903FB}"/>
-              </a:ext>
-            </a:extLst>
-          </p:cNvPr>
-          <p:cNvSpPr>
-            <a:spLocks xmlns:a="http://schemas.openxmlformats.org/drawingml/2006/main" noGrp="1"/>
-          </p:cNvSpPr>
-          <p:nvPr/>
-        </p:nvSpPr>
-        <p:spPr>
-          <a:xfrm xmlns:a="http://schemas.openxmlformats.org/drawingml/2006/main">
-            <a:off x="762000" y="971550"/>
-            <a:ext cx="4000500" cy="247650"/>
+          <p:cNvPr id="10" name="output-title">
+            <a:extLst xmlns:a="http://schemas.openxmlformats.org/drawingml/2006/main">
+              <a:ext uri="{FF2B5EF4-FFF2-40B4-BE49-F238E27FC236}">
+                <a16:creationId xmlns:a16="http://schemas.microsoft.com/office/drawing/2014/main" id="{F47525EA-91F7-4D2A-8766-B9776FB0164F}"/>
+              </a:ext>
+            </a:extLst>
+          </p:cNvPr>
+          <p:cNvSpPr>
+            <a:spLocks xmlns:a="http://schemas.openxmlformats.org/drawingml/2006/main" noGrp="1"/>
+          </p:cNvSpPr>
+          <p:nvPr/>
+        </p:nvSpPr>
+        <p:spPr>
+          <a:xfrm xmlns:a="http://schemas.openxmlformats.org/drawingml/2006/main">
+            <a:off x="762000" y="1466850"/>
+            <a:ext cx="4191000" cy="1409700"/>
           </a:xfrm>
           <a:prstGeom xmlns:a="http://schemas.openxmlformats.org/drawingml/2006/main" prst="rect">
             <a:avLst/>
@@ -3990,9 +3813,9 @@
           <a:p xmlns:a="http://schemas.openxmlformats.org/drawingml/2006/main">
             <a:pPr algn="l">
               <a:buNone/>
-              <a:defRPr sz="1125" b="1">
-                <a:solidFill>
-                  <a:srgbClr val="65D49A"/>
+              <a:defRPr sz="4350" b="1">
+                <a:solidFill>
+                  <a:srgbClr val="FFFFFF"/>
                 </a:solidFill>
                 <a:latin typeface="Arial"/>
                 <a:ea typeface="Arial"/>
@@ -4000,37 +3823,61 @@
               </a:defRPr>
             </a:pPr>
             <a:r>
-              <a:rPr sz="1125" b="1">
-                <a:solidFill>
-                  <a:srgbClr val="65D49A"/>
+              <a:rPr sz="4350" b="1">
+                <a:solidFill>
+                  <a:srgbClr val="FFFFFF"/>
                 </a:solidFill>
                 <a:latin typeface="Arial"/>
                 <a:ea typeface="Arial"/>
                 <a:cs typeface="Arial"/>
               </a:rPr>
-              <a:t>THE HUMAN HANDOFF</a:t>
+              <a:t>The therapist starts</a:t>
+            </a:r>
+          </a:p>
+          <a:p xmlns:a="http://schemas.openxmlformats.org/drawingml/2006/main">
+            <a:pPr algn="l">
+              <a:buNone/>
+              <a:defRPr sz="4350" b="1">
+                <a:solidFill>
+                  <a:srgbClr val="FFFFFF"/>
+                </a:solidFill>
+                <a:latin typeface="Arial"/>
+                <a:ea typeface="Arial"/>
+                <a:cs typeface="Arial"/>
+              </a:defRPr>
+            </a:pPr>
+            <a:r>
+              <a:rPr sz="4350" b="1">
+                <a:solidFill>
+                  <a:srgbClr val="FFFFFF"/>
+                </a:solidFill>
+                <a:latin typeface="Arial"/>
+                <a:ea typeface="Arial"/>
+                <a:cs typeface="Arial"/>
+              </a:rPr>
+              <a:t>with context.</a:t>
             </a:r>
           </a:p>
         </p:txBody>
       </p:sp>
       <p:sp>
         <p:nvSpPr>
-          <p:cNvPr id="10" name="output-title">
-            <a:extLst xmlns:a="http://schemas.openxmlformats.org/drawingml/2006/main">
-              <a:ext uri="{FF2B5EF4-FFF2-40B4-BE49-F238E27FC236}">
-                <a16:creationId xmlns:a16="http://schemas.microsoft.com/office/drawing/2014/main" id="{F47525EA-91F7-4D2A-8766-B9776FB0164F}"/>
-              </a:ext>
-            </a:extLst>
-          </p:cNvPr>
-          <p:cNvSpPr>
-            <a:spLocks xmlns:a="http://schemas.openxmlformats.org/drawingml/2006/main" noGrp="1"/>
-          </p:cNvSpPr>
-          <p:nvPr/>
-        </p:nvSpPr>
-        <p:spPr>
-          <a:xfrm xmlns:a="http://schemas.openxmlformats.org/drawingml/2006/main">
-            <a:off x="762000" y="1466850"/>
-            <a:ext cx="4191000" cy="1409700"/>
+          <p:cNvPr id="11" name="output-action">
+            <a:extLst xmlns:a="http://schemas.openxmlformats.org/drawingml/2006/main">
+              <a:ext uri="{FF2B5EF4-FFF2-40B4-BE49-F238E27FC236}">
+                <a16:creationId xmlns:a16="http://schemas.microsoft.com/office/drawing/2014/main" id="{D53125D5-C4E5-4D0C-90D7-98A55A1F9DCF}"/>
+              </a:ext>
+            </a:extLst>
+          </p:cNvPr>
+          <p:cNvSpPr>
+            <a:spLocks xmlns:a="http://schemas.openxmlformats.org/drawingml/2006/main" noGrp="1"/>
+          </p:cNvSpPr>
+          <p:nvPr/>
+        </p:nvSpPr>
+        <p:spPr>
+          <a:xfrm xmlns:a="http://schemas.openxmlformats.org/drawingml/2006/main">
+            <a:off x="762000" y="3390900"/>
+            <a:ext cx="4191000" cy="914400"/>
           </a:xfrm>
           <a:prstGeom xmlns:a="http://schemas.openxmlformats.org/drawingml/2006/main" prst="rect">
             <a:avLst/>
@@ -4049,9 +3896,9 @@
           <a:p xmlns:a="http://schemas.openxmlformats.org/drawingml/2006/main">
             <a:pPr algn="l">
               <a:buNone/>
-              <a:defRPr sz="4350" b="1">
-                <a:solidFill>
-                  <a:srgbClr val="FFFFFF"/>
+              <a:defRPr sz="2250" b="0">
+                <a:solidFill>
+                  <a:srgbClr val="EDEDED"/>
                 </a:solidFill>
                 <a:latin typeface="Arial"/>
                 <a:ea typeface="Arial"/>
@@ -4059,23 +3906,23 @@
               </a:defRPr>
             </a:pPr>
             <a:r>
-              <a:rPr sz="4350" b="1">
-                <a:solidFill>
-                  <a:srgbClr val="FFFFFF"/>
+              <a:rPr sz="2250" b="0">
+                <a:solidFill>
+                  <a:srgbClr val="EDEDED"/>
                 </a:solidFill>
                 <a:latin typeface="Arial"/>
                 <a:ea typeface="Arial"/>
                 <a:cs typeface="Arial"/>
               </a:rPr>
-              <a:t>The therapist starts</a:t>
+              <a:t>Maya still tells her story.</a:t>
             </a:r>
           </a:p>
           <a:p xmlns:a="http://schemas.openxmlformats.org/drawingml/2006/main">
             <a:pPr algn="l">
               <a:buNone/>
-              <a:defRPr sz="4350" b="1">
-                <a:solidFill>
-                  <a:srgbClr val="FFFFFF"/>
+              <a:defRPr sz="2250" b="0">
+                <a:solidFill>
+                  <a:srgbClr val="EDEDED"/>
                 </a:solidFill>
                 <a:latin typeface="Arial"/>
                 <a:ea typeface="Arial"/>
@@ -4083,37 +3930,70 @@
               </a:defRPr>
             </a:pPr>
             <a:r>
-              <a:rPr sz="4350" b="1">
-                <a:solidFill>
-                  <a:srgbClr val="FFFFFF"/>
+              <a:rPr sz="2250" b="0">
+                <a:solidFill>
+                  <a:srgbClr val="EDEDED"/>
                 </a:solidFill>
                 <a:latin typeface="Arial"/>
                 <a:ea typeface="Arial"/>
                 <a:cs typeface="Arial"/>
               </a:rPr>
-              <a:t>with context.</a:t>
+              <a:t>She just does not start from zero.</a:t>
             </a:r>
           </a:p>
         </p:txBody>
       </p:sp>
       <p:sp>
         <p:nvSpPr>
-          <p:cNvPr id="11" name="output-action">
-            <a:extLst xmlns:a="http://schemas.openxmlformats.org/drawingml/2006/main">
-              <a:ext uri="{FF2B5EF4-FFF2-40B4-BE49-F238E27FC236}">
-                <a16:creationId xmlns:a16="http://schemas.microsoft.com/office/drawing/2014/main" id="{D53125D5-C4E5-4D0C-90D7-98A55A1F9DCF}"/>
-              </a:ext>
-            </a:extLst>
-          </p:cNvPr>
-          <p:cNvSpPr>
-            <a:spLocks xmlns:a="http://schemas.openxmlformats.org/drawingml/2006/main" noGrp="1"/>
-          </p:cNvSpPr>
-          <p:nvPr/>
-        </p:nvSpPr>
-        <p:spPr>
-          <a:xfrm xmlns:a="http://schemas.openxmlformats.org/drawingml/2006/main">
-            <a:off x="762000" y="3390900"/>
-            <a:ext cx="4191000" cy="914400"/>
+          <p:cNvPr id="12" name="output-accent">
+            <a:extLst xmlns:a="http://schemas.openxmlformats.org/drawingml/2006/main">
+              <a:ext uri="{FF2B5EF4-FFF2-40B4-BE49-F238E27FC236}">
+                <a16:creationId xmlns:a16="http://schemas.microsoft.com/office/drawing/2014/main" id="{145FDA0B-C439-479F-A01C-7A70B8F36250}"/>
+              </a:ext>
+            </a:extLst>
+          </p:cNvPr>
+          <p:cNvSpPr>
+            <a:spLocks xmlns:a="http://schemas.openxmlformats.org/drawingml/2006/main" noGrp="1"/>
+          </p:cNvSpPr>
+          <p:nvPr/>
+        </p:nvSpPr>
+        <p:spPr>
+          <a:xfrm xmlns:a="http://schemas.openxmlformats.org/drawingml/2006/main">
+            <a:off x="762000" y="4762500"/>
+            <a:ext cx="609600" cy="28575"/>
+          </a:xfrm>
+          <a:prstGeom xmlns:a="http://schemas.openxmlformats.org/drawingml/2006/main" prst="rect">
+            <a:avLst/>
+          </a:prstGeom>
+          <a:solidFill xmlns:a="http://schemas.openxmlformats.org/drawingml/2006/main">
+            <a:srgbClr val="65D49A"/>
+          </a:solidFill>
+          <a:ln xmlns:a="http://schemas.openxmlformats.org/drawingml/2006/main" w="0">
+            <a:solidFill>
+              <a:srgbClr val="65D49A"/>
+            </a:solidFill>
+            <a:prstDash val="solid"/>
+          </a:ln>
+        </p:spPr>
+      </p:sp>
+      <p:sp>
+        <p:nvSpPr>
+          <p:cNvPr id="13" name="output-control">
+            <a:extLst xmlns:a="http://schemas.openxmlformats.org/drawingml/2006/main">
+              <a:ext uri="{FF2B5EF4-FFF2-40B4-BE49-F238E27FC236}">
+                <a16:creationId xmlns:a16="http://schemas.microsoft.com/office/drawing/2014/main" id="{18A7CBAC-C298-43F6-B690-42151F0E7734}"/>
+              </a:ext>
+            </a:extLst>
+          </p:cNvPr>
+          <p:cNvSpPr>
+            <a:spLocks xmlns:a="http://schemas.openxmlformats.org/drawingml/2006/main" noGrp="1"/>
+          </p:cNvSpPr>
+          <p:nvPr/>
+        </p:nvSpPr>
+        <p:spPr>
+          <a:xfrm xmlns:a="http://schemas.openxmlformats.org/drawingml/2006/main">
+            <a:off x="762000" y="5029200"/>
+            <a:ext cx="4191000" cy="647700"/>
           </a:xfrm>
           <a:prstGeom xmlns:a="http://schemas.openxmlformats.org/drawingml/2006/main" prst="rect">
             <a:avLst/>
@@ -4132,122 +4012,6 @@
           <a:p xmlns:a="http://schemas.openxmlformats.org/drawingml/2006/main">
             <a:pPr algn="l">
               <a:buNone/>
-              <a:defRPr sz="2250" b="0">
-                <a:solidFill>
-                  <a:srgbClr val="EDEDED"/>
-                </a:solidFill>
-                <a:latin typeface="Arial"/>
-                <a:ea typeface="Arial"/>
-                <a:cs typeface="Arial"/>
-              </a:defRPr>
-            </a:pPr>
-            <a:r>
-              <a:rPr sz="2250" b="0">
-                <a:solidFill>
-                  <a:srgbClr val="EDEDED"/>
-                </a:solidFill>
-                <a:latin typeface="Arial"/>
-                <a:ea typeface="Arial"/>
-                <a:cs typeface="Arial"/>
-              </a:rPr>
-              <a:t>Maya still tells her story.</a:t>
-            </a:r>
-          </a:p>
-          <a:p xmlns:a="http://schemas.openxmlformats.org/drawingml/2006/main">
-            <a:pPr algn="l">
-              <a:buNone/>
-              <a:defRPr sz="2250" b="0">
-                <a:solidFill>
-                  <a:srgbClr val="EDEDED"/>
-                </a:solidFill>
-                <a:latin typeface="Arial"/>
-                <a:ea typeface="Arial"/>
-                <a:cs typeface="Arial"/>
-              </a:defRPr>
-            </a:pPr>
-            <a:r>
-              <a:rPr sz="2250" b="0">
-                <a:solidFill>
-                  <a:srgbClr val="EDEDED"/>
-                </a:solidFill>
-                <a:latin typeface="Arial"/>
-                <a:ea typeface="Arial"/>
-                <a:cs typeface="Arial"/>
-              </a:rPr>
-              <a:t>She just does not start from zero.</a:t>
-            </a:r>
-          </a:p>
-        </p:txBody>
-      </p:sp>
-      <p:sp>
-        <p:nvSpPr>
-          <p:cNvPr id="12" name="output-accent">
-            <a:extLst xmlns:a="http://schemas.openxmlformats.org/drawingml/2006/main">
-              <a:ext uri="{FF2B5EF4-FFF2-40B4-BE49-F238E27FC236}">
-                <a16:creationId xmlns:a16="http://schemas.microsoft.com/office/drawing/2014/main" id="{145FDA0B-C439-479F-A01C-7A70B8F36250}"/>
-              </a:ext>
-            </a:extLst>
-          </p:cNvPr>
-          <p:cNvSpPr>
-            <a:spLocks xmlns:a="http://schemas.openxmlformats.org/drawingml/2006/main" noGrp="1"/>
-          </p:cNvSpPr>
-          <p:nvPr/>
-        </p:nvSpPr>
-        <p:spPr>
-          <a:xfrm xmlns:a="http://schemas.openxmlformats.org/drawingml/2006/main">
-            <a:off x="762000" y="4762500"/>
-            <a:ext cx="609600" cy="28575"/>
-          </a:xfrm>
-          <a:prstGeom xmlns:a="http://schemas.openxmlformats.org/drawingml/2006/main" prst="rect">
-            <a:avLst/>
-          </a:prstGeom>
-          <a:solidFill xmlns:a="http://schemas.openxmlformats.org/drawingml/2006/main">
-            <a:srgbClr val="65D49A"/>
-          </a:solidFill>
-          <a:ln xmlns:a="http://schemas.openxmlformats.org/drawingml/2006/main" w="0">
-            <a:solidFill>
-              <a:srgbClr val="65D49A"/>
-            </a:solidFill>
-            <a:prstDash val="solid"/>
-          </a:ln>
-        </p:spPr>
-      </p:sp>
-      <p:sp>
-        <p:nvSpPr>
-          <p:cNvPr id="13" name="output-control">
-            <a:extLst xmlns:a="http://schemas.openxmlformats.org/drawingml/2006/main">
-              <a:ext uri="{FF2B5EF4-FFF2-40B4-BE49-F238E27FC236}">
-                <a16:creationId xmlns:a16="http://schemas.microsoft.com/office/drawing/2014/main" id="{18A7CBAC-C298-43F6-B690-42151F0E7734}"/>
-              </a:ext>
-            </a:extLst>
-          </p:cNvPr>
-          <p:cNvSpPr>
-            <a:spLocks xmlns:a="http://schemas.openxmlformats.org/drawingml/2006/main" noGrp="1"/>
-          </p:cNvSpPr>
-          <p:nvPr/>
-        </p:nvSpPr>
-        <p:spPr>
-          <a:xfrm xmlns:a="http://schemas.openxmlformats.org/drawingml/2006/main">
-            <a:off x="762000" y="5029200"/>
-            <a:ext cx="4191000" cy="647700"/>
-          </a:xfrm>
-          <a:prstGeom xmlns:a="http://schemas.openxmlformats.org/drawingml/2006/main" prst="rect">
-            <a:avLst/>
-          </a:prstGeom>
-          <a:noFill xmlns:a="http://schemas.openxmlformats.org/drawingml/2006/main"/>
-          <a:ln xmlns:a="http://schemas.openxmlformats.org/drawingml/2006/main" w="0">
-            <a:noFill/>
-            <a:prstDash val="solid"/>
-          </a:ln>
-        </p:spPr>
-        <p:txBody>
-          <a:bodyPr xmlns:a="http://schemas.openxmlformats.org/drawingml/2006/main" wrap="square" lIns="0" tIns="0" rIns="0" bIns="0" anchor="t">
-            <a:noAutofit/>
-          </a:bodyPr>
-          <a:lstStyle xmlns:a="http://schemas.openxmlformats.org/drawingml/2006/main"/>
-          <a:p xmlns:a="http://schemas.openxmlformats.org/drawingml/2006/main">
-            <a:pPr algn="l">
-              <a:buNone/>
               <a:defRPr sz="1500" b="0">
                 <a:solidFill>
                   <a:srgbClr val="A1A1A1"/>
@@ -4330,14 +4094,14 @@
       </p:sp>
       <p:pic>
         <p:nvPicPr>
-          <p:cNvPr id="32" name=""/>
+          <p:cNvPr id="31" name=""/>
           <p:cNvPicPr>
             <a:picLocks xmlns:a="http://schemas.openxmlformats.org/drawingml/2006/main" noChangeAspect="1"/>
           </p:cNvPicPr>
           <p:nvPr/>
         </p:nvPicPr>
         <p:blipFill>
-          <a:blip xmlns:r="http://schemas.openxmlformats.org/officeDocument/2006/relationships" xmlns:a="http://schemas.openxmlformats.org/drawingml/2006/main" r:embed="R5ad6fc031c4047ce"/>
+          <a:blip xmlns:r="http://schemas.openxmlformats.org/officeDocument/2006/relationships" xmlns:a="http://schemas.openxmlformats.org/drawingml/2006/main" r:embed="R8d8e8944d6c54b50"/>
           <a:srcRect xmlns:a="http://schemas.openxmlformats.org/drawingml/2006/main" l="16147" t="0" r="16147" b="0"/>
           <a:stretch xmlns:a="http://schemas.openxmlformats.org/drawingml/2006/main">
             <a:fillRect l="0" t="0" r="0" b="0"/>

</xml_diff>